<commit_message>
Deck cut to 8 slides (problem, architecture, FDB-v3 results, extension, next); README marks the extension use case
Co-authored-by: hainasehrawat120 <180665540+hainasehrawat120@users.noreply.github.com>
</commit_message>
<xml_diff>
--- a/docs/SRMIST_krenos_Submission.pptx
+++ b/docs/SRMIST_krenos_Submission.pptx
@@ -10,14 +10,10 @@
   <p:sldIdLst>
     <p:sldId id="256" r:id="rId5"/>
     <p:sldId id="257" r:id="rId6"/>
-    <p:sldId id="258" r:id="rId7"/>
     <p:sldId id="259" r:id="rId8"/>
-    <p:sldId id="260" r:id="rId9"/>
-    <p:sldId id="261" r:id="rId10"/>
+    <p:sldId id="263" r:id="rId12"/>
     <p:sldId id="262" r:id="rId11"/>
-    <p:sldId id="263" r:id="rId12"/>
     <p:sldId id="264" r:id="rId13"/>
-    <p:sldId id="265" r:id="rId14"/>
     <p:sldId id="266" r:id="rId15"/>
     <p:sldId id="267" r:id="rId16"/>
   </p:sldIdLst>
@@ -1585,105 +1581,6 @@
 </p:notes>
 </file>
 
-<file path=ppt/notesSlides/notesSlide10.xml><?xml version="1.0" encoding="utf-8"?>
-<p:notes xmlns:a="http://schemas.openxmlformats.org/drawingml/2006/main" xmlns:r="http://schemas.openxmlformats.org/officeDocument/2006/relationships" xmlns:mc="http://schemas.openxmlformats.org/markup-compatibility/2006" xmlns:mv="urn:schemas-microsoft-com:mac:vml" xmlns:p="http://schemas.openxmlformats.org/presentationml/2006/main" xmlns:c="http://schemas.openxmlformats.org/drawingml/2006/chart" xmlns:dgm="http://schemas.openxmlformats.org/drawingml/2006/diagram" xmlns:o="urn:schemas-microsoft-com:office:office" xmlns:v="urn:schemas-microsoft-com:vml" xmlns:pvml="urn:schemas-microsoft-com:office:powerpoint" xmlns:com="http://schemas.openxmlformats.org/drawingml/2006/compatibility" xmlns:p14="http://schemas.microsoft.com/office/powerpoint/2010/main" xmlns:p15="http://schemas.microsoft.com/office/powerpoint/2012/main" xmlns:ahyp="http://schemas.microsoft.com/office/drawing/2018/hyperlinkcolor" showMasterPhAnim="0" showMasterSp="0">
-  <p:cSld>
-    <p:spTree>
-      <p:nvGrpSpPr>
-        <p:cNvPr id="145" name="Shape 145"/>
-        <p:cNvGrpSpPr/>
-        <p:nvPr/>
-      </p:nvGrpSpPr>
-      <p:grpSpPr>
-        <a:xfrm>
-          <a:off x="0" y="0"/>
-          <a:ext cx="0" cy="0"/>
-          <a:chOff x="0" y="0"/>
-          <a:chExt cx="0" cy="0"/>
-        </a:xfrm>
-      </p:grpSpPr>
-      <p:sp>
-        <p:nvSpPr>
-          <p:cNvPr id="146" name="Google Shape;146;p10:notes"/>
-          <p:cNvSpPr txBox="1"/>
-          <p:nvPr>
-            <p:ph idx="1" type="body"/>
-          </p:nvPr>
-        </p:nvSpPr>
-        <p:spPr>
-          <a:xfrm>
-            <a:off x="685800" y="4400550"/>
-            <a:ext cx="5486400" cy="3600450"/>
-          </a:xfrm>
-          <a:prstGeom prst="rect">
-            <a:avLst/>
-          </a:prstGeom>
-        </p:spPr>
-        <p:txBody>
-          <a:bodyPr anchorCtr="0" anchor="t" bIns="45700" lIns="91425" spcFirstLastPara="1" rIns="91425" wrap="square" tIns="45700">
-            <a:noAutofit/>
-          </a:bodyPr>
-          <a:lstStyle/>
-          <a:p>
-            <a:pPr indent="0" lvl="0" marL="0" rtl="0" algn="l">
-              <a:spcBef>
-                <a:spcPts val="0"/>
-              </a:spcBef>
-              <a:spcAft>
-                <a:spcPts val="0"/>
-              </a:spcAft>
-              <a:buNone/>
-            </a:pPr>
-            <a:r>
-              <a:t/>
-            </a:r>
-            <a:endParaRPr/>
-          </a:p>
-        </p:txBody>
-      </p:sp>
-      <p:sp>
-        <p:nvSpPr>
-          <p:cNvPr id="147" name="Google Shape;147;p10:notes"/>
-          <p:cNvSpPr/>
-          <p:nvPr>
-            <p:ph idx="2" type="sldImg"/>
-          </p:nvPr>
-        </p:nvSpPr>
-        <p:spPr>
-          <a:xfrm>
-            <a:off x="685800" y="1143000"/>
-            <a:ext cx="5486400" cy="3086100"/>
-          </a:xfrm>
-          <a:custGeom>
-            <a:rect b="b" l="l" r="r" t="t"/>
-            <a:pathLst>
-              <a:path extrusionOk="0" h="120000" w="120000">
-                <a:moveTo>
-                  <a:pt x="0" y="0"/>
-                </a:moveTo>
-                <a:lnTo>
-                  <a:pt x="120000" y="0"/>
-                </a:lnTo>
-                <a:lnTo>
-                  <a:pt x="120000" y="120000"/>
-                </a:lnTo>
-                <a:lnTo>
-                  <a:pt x="0" y="120000"/>
-                </a:lnTo>
-                <a:close/>
-              </a:path>
-            </a:pathLst>
-          </a:custGeom>
-        </p:spPr>
-      </p:sp>
-    </p:spTree>
-  </p:cSld>
-  <p:clrMapOvr>
-    <a:masterClrMapping/>
-  </p:clrMapOvr>
-</p:notes>
-</file>
-
 <file path=ppt/notesSlides/notesSlide11.xml><?xml version="1.0" encoding="utf-8"?>
 <p:notes xmlns:a="http://schemas.openxmlformats.org/drawingml/2006/main" xmlns:r="http://schemas.openxmlformats.org/officeDocument/2006/relationships" xmlns:mc="http://schemas.openxmlformats.org/markup-compatibility/2006" xmlns:mv="urn:schemas-microsoft-com:mac:vml" xmlns:p="http://schemas.openxmlformats.org/presentationml/2006/main" xmlns:c="http://schemas.openxmlformats.org/drawingml/2006/chart" xmlns:dgm="http://schemas.openxmlformats.org/drawingml/2006/diagram" xmlns:o="urn:schemas-microsoft-com:office:office" xmlns:v="urn:schemas-microsoft-com:vml" xmlns:pvml="urn:schemas-microsoft-com:office:powerpoint" xmlns:com="http://schemas.openxmlformats.org/drawingml/2006/compatibility" xmlns:p14="http://schemas.microsoft.com/office/powerpoint/2010/main" xmlns:p15="http://schemas.microsoft.com/office/powerpoint/2012/main" xmlns:ahyp="http://schemas.microsoft.com/office/drawing/2018/hyperlinkcolor" showMasterPhAnim="0" showMasterSp="0">
   <p:cSld>
@@ -2040,105 +1937,6 @@
 </p:notes>
 </file>
 
-<file path=ppt/notesSlides/notesSlide3.xml><?xml version="1.0" encoding="utf-8"?>
-<p:notes xmlns:a="http://schemas.openxmlformats.org/drawingml/2006/main" xmlns:r="http://schemas.openxmlformats.org/officeDocument/2006/relationships" xmlns:mc="http://schemas.openxmlformats.org/markup-compatibility/2006" xmlns:mv="urn:schemas-microsoft-com:mac:vml" xmlns:p="http://schemas.openxmlformats.org/presentationml/2006/main" xmlns:c="http://schemas.openxmlformats.org/drawingml/2006/chart" xmlns:dgm="http://schemas.openxmlformats.org/drawingml/2006/diagram" xmlns:o="urn:schemas-microsoft-com:office:office" xmlns:v="urn:schemas-microsoft-com:vml" xmlns:pvml="urn:schemas-microsoft-com:office:powerpoint" xmlns:com="http://schemas.openxmlformats.org/drawingml/2006/compatibility" xmlns:p14="http://schemas.microsoft.com/office/powerpoint/2010/main" xmlns:p15="http://schemas.microsoft.com/office/powerpoint/2012/main" xmlns:ahyp="http://schemas.microsoft.com/office/drawing/2018/hyperlinkcolor" showMasterPhAnim="0" showMasterSp="0">
-  <p:cSld>
-    <p:spTree>
-      <p:nvGrpSpPr>
-        <p:cNvPr id="103" name="Shape 103"/>
-        <p:cNvGrpSpPr/>
-        <p:nvPr/>
-      </p:nvGrpSpPr>
-      <p:grpSpPr>
-        <a:xfrm>
-          <a:off x="0" y="0"/>
-          <a:ext cx="0" cy="0"/>
-          <a:chOff x="0" y="0"/>
-          <a:chExt cx="0" cy="0"/>
-        </a:xfrm>
-      </p:grpSpPr>
-      <p:sp>
-        <p:nvSpPr>
-          <p:cNvPr id="104" name="Google Shape;104;p3:notes"/>
-          <p:cNvSpPr txBox="1"/>
-          <p:nvPr>
-            <p:ph idx="1" type="body"/>
-          </p:nvPr>
-        </p:nvSpPr>
-        <p:spPr>
-          <a:xfrm>
-            <a:off x="685800" y="4400550"/>
-            <a:ext cx="5486400" cy="3600450"/>
-          </a:xfrm>
-          <a:prstGeom prst="rect">
-            <a:avLst/>
-          </a:prstGeom>
-        </p:spPr>
-        <p:txBody>
-          <a:bodyPr anchorCtr="0" anchor="t" bIns="45700" lIns="91425" spcFirstLastPara="1" rIns="91425" wrap="square" tIns="45700">
-            <a:noAutofit/>
-          </a:bodyPr>
-          <a:lstStyle/>
-          <a:p>
-            <a:pPr indent="0" lvl="0" marL="0" rtl="0" algn="l">
-              <a:spcBef>
-                <a:spcPts val="0"/>
-              </a:spcBef>
-              <a:spcAft>
-                <a:spcPts val="0"/>
-              </a:spcAft>
-              <a:buNone/>
-            </a:pPr>
-            <a:r>
-              <a:t/>
-            </a:r>
-            <a:endParaRPr/>
-          </a:p>
-        </p:txBody>
-      </p:sp>
-      <p:sp>
-        <p:nvSpPr>
-          <p:cNvPr id="105" name="Google Shape;105;p3:notes"/>
-          <p:cNvSpPr/>
-          <p:nvPr>
-            <p:ph idx="2" type="sldImg"/>
-          </p:nvPr>
-        </p:nvSpPr>
-        <p:spPr>
-          <a:xfrm>
-            <a:off x="685800" y="1143000"/>
-            <a:ext cx="5486400" cy="3086100"/>
-          </a:xfrm>
-          <a:custGeom>
-            <a:rect b="b" l="l" r="r" t="t"/>
-            <a:pathLst>
-              <a:path extrusionOk="0" h="120000" w="120000">
-                <a:moveTo>
-                  <a:pt x="0" y="0"/>
-                </a:moveTo>
-                <a:lnTo>
-                  <a:pt x="120000" y="0"/>
-                </a:lnTo>
-                <a:lnTo>
-                  <a:pt x="120000" y="120000"/>
-                </a:lnTo>
-                <a:lnTo>
-                  <a:pt x="0" y="120000"/>
-                </a:lnTo>
-                <a:close/>
-              </a:path>
-            </a:pathLst>
-          </a:custGeom>
-        </p:spPr>
-      </p:sp>
-    </p:spTree>
-  </p:cSld>
-  <p:clrMapOvr>
-    <a:masterClrMapping/>
-  </p:clrMapOvr>
-</p:notes>
-</file>
-
 <file path=ppt/notesSlides/notesSlide4.xml><?xml version="1.0" encoding="utf-8"?>
 <p:notes xmlns:a="http://schemas.openxmlformats.org/drawingml/2006/main" xmlns:r="http://schemas.openxmlformats.org/officeDocument/2006/relationships" xmlns:mc="http://schemas.openxmlformats.org/markup-compatibility/2006" xmlns:mv="urn:schemas-microsoft-com:mac:vml" xmlns:p="http://schemas.openxmlformats.org/presentationml/2006/main" xmlns:c="http://schemas.openxmlformats.org/drawingml/2006/chart" xmlns:dgm="http://schemas.openxmlformats.org/drawingml/2006/diagram" xmlns:o="urn:schemas-microsoft-com:office:office" xmlns:v="urn:schemas-microsoft-com:vml" xmlns:pvml="urn:schemas-microsoft-com:office:powerpoint" xmlns:com="http://schemas.openxmlformats.org/drawingml/2006/compatibility" xmlns:p14="http://schemas.microsoft.com/office/powerpoint/2010/main" xmlns:p15="http://schemas.microsoft.com/office/powerpoint/2012/main" xmlns:ahyp="http://schemas.microsoft.com/office/drawing/2018/hyperlinkcolor" showMasterPhAnim="0" showMasterSp="0">
   <p:cSld>
@@ -2198,204 +1996,6 @@
       <p:sp>
         <p:nvSpPr>
           <p:cNvPr id="111" name="Google Shape;111;p4:notes"/>
-          <p:cNvSpPr/>
-          <p:nvPr>
-            <p:ph idx="2" type="sldImg"/>
-          </p:nvPr>
-        </p:nvSpPr>
-        <p:spPr>
-          <a:xfrm>
-            <a:off x="685800" y="1143000"/>
-            <a:ext cx="5486400" cy="3086100"/>
-          </a:xfrm>
-          <a:custGeom>
-            <a:rect b="b" l="l" r="r" t="t"/>
-            <a:pathLst>
-              <a:path extrusionOk="0" h="120000" w="120000">
-                <a:moveTo>
-                  <a:pt x="0" y="0"/>
-                </a:moveTo>
-                <a:lnTo>
-                  <a:pt x="120000" y="0"/>
-                </a:lnTo>
-                <a:lnTo>
-                  <a:pt x="120000" y="120000"/>
-                </a:lnTo>
-                <a:lnTo>
-                  <a:pt x="0" y="120000"/>
-                </a:lnTo>
-                <a:close/>
-              </a:path>
-            </a:pathLst>
-          </a:custGeom>
-        </p:spPr>
-      </p:sp>
-    </p:spTree>
-  </p:cSld>
-  <p:clrMapOvr>
-    <a:masterClrMapping/>
-  </p:clrMapOvr>
-</p:notes>
-</file>
-
-<file path=ppt/notesSlides/notesSlide5.xml><?xml version="1.0" encoding="utf-8"?>
-<p:notes xmlns:a="http://schemas.openxmlformats.org/drawingml/2006/main" xmlns:r="http://schemas.openxmlformats.org/officeDocument/2006/relationships" xmlns:mc="http://schemas.openxmlformats.org/markup-compatibility/2006" xmlns:mv="urn:schemas-microsoft-com:mac:vml" xmlns:p="http://schemas.openxmlformats.org/presentationml/2006/main" xmlns:c="http://schemas.openxmlformats.org/drawingml/2006/chart" xmlns:dgm="http://schemas.openxmlformats.org/drawingml/2006/diagram" xmlns:o="urn:schemas-microsoft-com:office:office" xmlns:v="urn:schemas-microsoft-com:vml" xmlns:pvml="urn:schemas-microsoft-com:office:powerpoint" xmlns:com="http://schemas.openxmlformats.org/drawingml/2006/compatibility" xmlns:p14="http://schemas.microsoft.com/office/powerpoint/2010/main" xmlns:p15="http://schemas.microsoft.com/office/powerpoint/2012/main" xmlns:ahyp="http://schemas.microsoft.com/office/drawing/2018/hyperlinkcolor" showMasterPhAnim="0" showMasterSp="0">
-  <p:cSld>
-    <p:spTree>
-      <p:nvGrpSpPr>
-        <p:cNvPr id="115" name="Shape 115"/>
-        <p:cNvGrpSpPr/>
-        <p:nvPr/>
-      </p:nvGrpSpPr>
-      <p:grpSpPr>
-        <a:xfrm>
-          <a:off x="0" y="0"/>
-          <a:ext cx="0" cy="0"/>
-          <a:chOff x="0" y="0"/>
-          <a:chExt cx="0" cy="0"/>
-        </a:xfrm>
-      </p:grpSpPr>
-      <p:sp>
-        <p:nvSpPr>
-          <p:cNvPr id="116" name="Google Shape;116;p5:notes"/>
-          <p:cNvSpPr txBox="1"/>
-          <p:nvPr>
-            <p:ph idx="1" type="body"/>
-          </p:nvPr>
-        </p:nvSpPr>
-        <p:spPr>
-          <a:xfrm>
-            <a:off x="685800" y="4400550"/>
-            <a:ext cx="5486400" cy="3600450"/>
-          </a:xfrm>
-          <a:prstGeom prst="rect">
-            <a:avLst/>
-          </a:prstGeom>
-        </p:spPr>
-        <p:txBody>
-          <a:bodyPr anchorCtr="0" anchor="t" bIns="45700" lIns="91425" spcFirstLastPara="1" rIns="91425" wrap="square" tIns="45700">
-            <a:noAutofit/>
-          </a:bodyPr>
-          <a:lstStyle/>
-          <a:p>
-            <a:pPr indent="0" lvl="0" marL="0" rtl="0" algn="l">
-              <a:spcBef>
-                <a:spcPts val="0"/>
-              </a:spcBef>
-              <a:spcAft>
-                <a:spcPts val="0"/>
-              </a:spcAft>
-              <a:buNone/>
-            </a:pPr>
-            <a:r>
-              <a:t/>
-            </a:r>
-            <a:endParaRPr/>
-          </a:p>
-        </p:txBody>
-      </p:sp>
-      <p:sp>
-        <p:nvSpPr>
-          <p:cNvPr id="117" name="Google Shape;117;p5:notes"/>
-          <p:cNvSpPr/>
-          <p:nvPr>
-            <p:ph idx="2" type="sldImg"/>
-          </p:nvPr>
-        </p:nvSpPr>
-        <p:spPr>
-          <a:xfrm>
-            <a:off x="685800" y="1143000"/>
-            <a:ext cx="5486400" cy="3086100"/>
-          </a:xfrm>
-          <a:custGeom>
-            <a:rect b="b" l="l" r="r" t="t"/>
-            <a:pathLst>
-              <a:path extrusionOk="0" h="120000" w="120000">
-                <a:moveTo>
-                  <a:pt x="0" y="0"/>
-                </a:moveTo>
-                <a:lnTo>
-                  <a:pt x="120000" y="0"/>
-                </a:lnTo>
-                <a:lnTo>
-                  <a:pt x="120000" y="120000"/>
-                </a:lnTo>
-                <a:lnTo>
-                  <a:pt x="0" y="120000"/>
-                </a:lnTo>
-                <a:close/>
-              </a:path>
-            </a:pathLst>
-          </a:custGeom>
-        </p:spPr>
-      </p:sp>
-    </p:spTree>
-  </p:cSld>
-  <p:clrMapOvr>
-    <a:masterClrMapping/>
-  </p:clrMapOvr>
-</p:notes>
-</file>
-
-<file path=ppt/notesSlides/notesSlide6.xml><?xml version="1.0" encoding="utf-8"?>
-<p:notes xmlns:a="http://schemas.openxmlformats.org/drawingml/2006/main" xmlns:r="http://schemas.openxmlformats.org/officeDocument/2006/relationships" xmlns:mc="http://schemas.openxmlformats.org/markup-compatibility/2006" xmlns:mv="urn:schemas-microsoft-com:mac:vml" xmlns:p="http://schemas.openxmlformats.org/presentationml/2006/main" xmlns:c="http://schemas.openxmlformats.org/drawingml/2006/chart" xmlns:dgm="http://schemas.openxmlformats.org/drawingml/2006/diagram" xmlns:o="urn:schemas-microsoft-com:office:office" xmlns:v="urn:schemas-microsoft-com:vml" xmlns:pvml="urn:schemas-microsoft-com:office:powerpoint" xmlns:com="http://schemas.openxmlformats.org/drawingml/2006/compatibility" xmlns:p14="http://schemas.microsoft.com/office/powerpoint/2010/main" xmlns:p15="http://schemas.microsoft.com/office/powerpoint/2012/main" xmlns:ahyp="http://schemas.microsoft.com/office/drawing/2018/hyperlinkcolor" showMasterPhAnim="0" showMasterSp="0">
-  <p:cSld>
-    <p:spTree>
-      <p:nvGrpSpPr>
-        <p:cNvPr id="121" name="Shape 121"/>
-        <p:cNvGrpSpPr/>
-        <p:nvPr/>
-      </p:nvGrpSpPr>
-      <p:grpSpPr>
-        <a:xfrm>
-          <a:off x="0" y="0"/>
-          <a:ext cx="0" cy="0"/>
-          <a:chOff x="0" y="0"/>
-          <a:chExt cx="0" cy="0"/>
-        </a:xfrm>
-      </p:grpSpPr>
-      <p:sp>
-        <p:nvSpPr>
-          <p:cNvPr id="122" name="Google Shape;122;p6:notes"/>
-          <p:cNvSpPr txBox="1"/>
-          <p:nvPr>
-            <p:ph idx="1" type="body"/>
-          </p:nvPr>
-        </p:nvSpPr>
-        <p:spPr>
-          <a:xfrm>
-            <a:off x="685800" y="4400550"/>
-            <a:ext cx="5486400" cy="3600450"/>
-          </a:xfrm>
-          <a:prstGeom prst="rect">
-            <a:avLst/>
-          </a:prstGeom>
-        </p:spPr>
-        <p:txBody>
-          <a:bodyPr anchorCtr="0" anchor="t" bIns="45700" lIns="91425" spcFirstLastPara="1" rIns="91425" wrap="square" tIns="45700">
-            <a:noAutofit/>
-          </a:bodyPr>
-          <a:lstStyle/>
-          <a:p>
-            <a:pPr indent="0" lvl="0" marL="0" rtl="0" algn="l">
-              <a:spcBef>
-                <a:spcPts val="0"/>
-              </a:spcBef>
-              <a:spcAft>
-                <a:spcPts val="0"/>
-              </a:spcAft>
-              <a:buNone/>
-            </a:pPr>
-            <a:r>
-              <a:t/>
-            </a:r>
-            <a:endParaRPr/>
-          </a:p>
-        </p:txBody>
-      </p:sp>
-      <p:sp>
-        <p:nvSpPr>
-          <p:cNvPr id="123" name="Google Shape;123;p6:notes"/>
           <p:cNvSpPr/>
           <p:nvPr>
             <p:ph idx="2" type="sldImg"/>
@@ -13348,7 +12948,7 @@
                 <a:cs typeface="Calibri"/>
                 <a:sym typeface="Calibri"/>
               </a:rPr>
-              <a:t>Submission Github link - </a:t>
+              <a:t>Submission Github link - github.com/Darsh-14/Audient</a:t>
             </a:r>
             <a:endParaRPr/>
           </a:p>
@@ -13450,596 +13050,6 @@
 </p:sld>
 </file>
 
-<file path=ppt/slides/slide10.xml><?xml version="1.0" encoding="utf-8"?>
-<p:sld xmlns:a="http://schemas.openxmlformats.org/drawingml/2006/main" xmlns:r="http://schemas.openxmlformats.org/officeDocument/2006/relationships" xmlns:mc="http://schemas.openxmlformats.org/markup-compatibility/2006" xmlns:mv="urn:schemas-microsoft-com:mac:vml" xmlns:p="http://schemas.openxmlformats.org/presentationml/2006/main" xmlns:c="http://schemas.openxmlformats.org/drawingml/2006/chart" xmlns:dgm="http://schemas.openxmlformats.org/drawingml/2006/diagram" xmlns:o="urn:schemas-microsoft-com:office:office" xmlns:v="urn:schemas-microsoft-com:vml" xmlns:pvml="urn:schemas-microsoft-com:office:powerpoint" xmlns:com="http://schemas.openxmlformats.org/drawingml/2006/compatibility" xmlns:p14="http://schemas.microsoft.com/office/powerpoint/2010/main" xmlns:p15="http://schemas.microsoft.com/office/powerpoint/2012/main" xmlns:ahyp="http://schemas.microsoft.com/office/drawing/2018/hyperlinkcolor">
-  <p:cSld>
-    <p:spTree>
-      <p:nvGrpSpPr>
-        <p:cNvPr id="148" name="Shape 148"/>
-        <p:cNvGrpSpPr/>
-        <p:nvPr/>
-      </p:nvGrpSpPr>
-      <p:grpSpPr>
-        <a:xfrm>
-          <a:off x="0" y="0"/>
-          <a:ext cx="0" cy="0"/>
-          <a:chOff x="0" y="0"/>
-          <a:chExt cx="0" cy="0"/>
-        </a:xfrm>
-      </p:grpSpPr>
-      <p:sp>
-        <p:nvSpPr>
-          <p:cNvPr id="149" name="Google Shape;149;p10"/>
-          <p:cNvSpPr txBox="1"/>
-          <p:nvPr>
-            <p:ph type="title"/>
-          </p:nvPr>
-        </p:nvSpPr>
-        <p:spPr>
-          <a:xfrm>
-            <a:off x="548640" y="201168"/>
-            <a:ext cx="11064240" cy="868680"/>
-          </a:xfrm>
-          <a:prstGeom prst="rect">
-            <a:avLst/>
-          </a:prstGeom>
-          <a:noFill/>
-          <a:ln>
-            <a:noFill/>
-          </a:ln>
-        </p:spPr>
-        <p:txBody>
-          <a:bodyPr anchorCtr="0" anchor="ctr" bIns="45700" lIns="91425" spcFirstLastPara="1" rIns="91425" wrap="square" tIns="45700">
-            <a:normAutofit/>
-          </a:bodyPr>
-          <a:lstStyle/>
-          <a:p>
-            <a:pPr indent="0" lvl="0" marL="0" rtl="0" algn="l">
-              <a:lnSpc>
-                <a:spcPct val="90000"/>
-              </a:lnSpc>
-              <a:spcBef>
-                <a:spcPts val="0"/>
-              </a:spcBef>
-              <a:spcAft>
-                <a:spcPts val="0"/>
-              </a:spcAft>
-              <a:buClr>
-                <a:srgbClr val="704EA6"/>
-              </a:buClr>
-              <a:buSzPts val="4400"/>
-              <a:buFont typeface="Calibri"/>
-              <a:buNone/>
-            </a:pPr>
-            <a:r>
-              <a:rPr b="1" lang="en-US" sz="3800">
-                <a:solidFill>
-                  <a:srgbClr val="704EA6"/>
-                </a:solidFill>
-                <a:latin typeface="Calibri"/>
-                <a:ea typeface="Calibri"/>
-                <a:cs typeface="Calibri"/>
-                <a:sym typeface="Calibri"/>
-              </a:rPr>
-              <a:t>Brownie points slide( differentiation)</a:t>
-            </a:r>
-            <a:endParaRPr b="1" sz="4400">
-              <a:solidFill>
-                <a:srgbClr val="704EA6"/>
-              </a:solidFill>
-            </a:endParaRPr>
-          </a:p>
-        </p:txBody>
-      </p:sp>
-      <p:sp>
-        <p:nvSpPr>
-          <p:cNvPr id="150" name="TextBox 149"/>
-          <p:cNvSpPr txBox="1"/>
-          <p:nvPr/>
-        </p:nvSpPr>
-        <p:spPr>
-          <a:xfrm>
-            <a:off x="566928" y="1051560"/>
-            <a:ext cx="11064240" cy="411480"/>
-          </a:xfrm>
-          <a:prstGeom prst="rect">
-            <a:avLst/>
-          </a:prstGeom>
-          <a:noFill/>
-        </p:spPr>
-        <p:txBody>
-          <a:bodyPr wrap="square">
-            <a:spAutoFit/>
-          </a:bodyPr>
-          <a:lstStyle/>
-          <a:p>
-            <a:r>
-              <a:rPr sz="1500" b="1">
-                <a:solidFill>
-                  <a:srgbClr val="6D28D9"/>
-                </a:solidFill>
-              </a:rPr>
-              <a:t>Why Audient stands out</a:t>
-            </a:r>
-          </a:p>
-        </p:txBody>
-      </p:sp>
-      <p:sp>
-        <p:nvSpPr>
-          <p:cNvPr id="151" name="Rounded Rectangle 150"/>
-          <p:cNvSpPr/>
-          <p:nvPr/>
-        </p:nvSpPr>
-        <p:spPr>
-          <a:xfrm>
-            <a:off x="548640" y="1645920"/>
-            <a:ext cx="5440680" cy="2377440"/>
-          </a:xfrm>
-          <a:prstGeom prst="roundRect">
-            <a:avLst>
-              <a:gd name="adj" fmla="val 6000"/>
-            </a:avLst>
-          </a:prstGeom>
-          <a:solidFill>
-            <a:srgbClr val="F8F9FB"/>
-          </a:solidFill>
-          <a:ln w="19050">
-            <a:solidFill>
-              <a:srgbClr val="6D28D9"/>
-            </a:solidFill>
-          </a:ln>
-          <a:effectLst/>
-        </p:spPr>
-        <p:style>
-          <a:lnRef idx="1">
-            <a:schemeClr val="accent1"/>
-          </a:lnRef>
-          <a:fillRef idx="3">
-            <a:schemeClr val="accent1"/>
-          </a:fillRef>
-          <a:effectRef idx="2">
-            <a:schemeClr val="accent1"/>
-          </a:effectRef>
-          <a:fontRef idx="minor">
-            <a:schemeClr val="lt1"/>
-          </a:fontRef>
-        </p:style>
-        <p:txBody>
-          <a:bodyPr rtlCol="0" anchor="t" wrap="square" lIns="146304" rIns="146304" tIns="109728"/>
-          <a:lstStyle/>
-          <a:p>
-            <a:pPr algn="ctr"/>
-            <a:r>
-              <a:rPr sz="1650" b="1">
-                <a:solidFill>
-                  <a:srgbClr val="6D28D9"/>
-                </a:solidFill>
-              </a:rPr>
-              <a:t>VERIFIABLE</a:t>
-            </a:r>
-          </a:p>
-          <a:p>
-            <a:pPr algn="ctr">
-              <a:spcAft>
-                <a:spcPts val="400"/>
-              </a:spcAft>
-            </a:pPr>
-            <a:r>
-              <a:rPr sz="1450" b="1">
-                <a:solidFill>
-                  <a:srgbClr val="111827"/>
-                </a:solidFill>
-              </a:rPr>
-              <a:t>Every claim has a trace</a:t>
-            </a:r>
-          </a:p>
-          <a:p>
-            <a:pPr>
-              <a:spcBef>
-                <a:spcPts val="300"/>
-              </a:spcBef>
-            </a:pPr>
-            <a:r>
-              <a:rPr sz="1250" b="1">
-                <a:solidFill>
-                  <a:srgbClr val="111827"/>
-                </a:solidFill>
-              </a:rPr>
-              <a:t>• Deterministic mock tools + virtual clock: </a:t>
-            </a:r>
-            <a:r>
-              <a:rPr sz="1250">
-                <a:solidFill>
-                  <a:srgbClr val="475569"/>
-                </a:solidFill>
-              </a:rPr>
-              <a:t>the jury can replay any scenario and read each timestamped action.</a:t>
-            </a:r>
-          </a:p>
-          <a:p>
-            <a:pPr>
-              <a:spcBef>
-                <a:spcPts val="300"/>
-              </a:spcBef>
-            </a:pPr>
-            <a:r>
-              <a:rPr sz="1250" b="1">
-                <a:solidFill>
-                  <a:srgbClr val="111827"/>
-                </a:solidFill>
-              </a:rPr>
-              <a:t>• One command: </a:t>
-            </a:r>
-            <a:r>
-              <a:rPr sz="1250">
-                <a:solidFill>
-                  <a:srgbClr val="475569"/>
-                </a:solidFill>
-              </a:rPr>
-              <a:t>./run_evaluation.sh (tests + benchmark + baseline comparison).</a:t>
-            </a:r>
-          </a:p>
-        </p:txBody>
-      </p:sp>
-      <p:sp>
-        <p:nvSpPr>
-          <p:cNvPr id="152" name="Rounded Rectangle 151"/>
-          <p:cNvSpPr/>
-          <p:nvPr/>
-        </p:nvSpPr>
-        <p:spPr>
-          <a:xfrm>
-            <a:off x="6217920" y="1645920"/>
-            <a:ext cx="5440680" cy="2377440"/>
-          </a:xfrm>
-          <a:prstGeom prst="roundRect">
-            <a:avLst>
-              <a:gd name="adj" fmla="val 6000"/>
-            </a:avLst>
-          </a:prstGeom>
-          <a:solidFill>
-            <a:srgbClr val="F8F9FB"/>
-          </a:solidFill>
-          <a:ln w="19050">
-            <a:solidFill>
-              <a:srgbClr val="DC2626"/>
-            </a:solidFill>
-          </a:ln>
-          <a:effectLst/>
-        </p:spPr>
-        <p:style>
-          <a:lnRef idx="1">
-            <a:schemeClr val="accent1"/>
-          </a:lnRef>
-          <a:fillRef idx="3">
-            <a:schemeClr val="accent1"/>
-          </a:fillRef>
-          <a:effectRef idx="2">
-            <a:schemeClr val="accent1"/>
-          </a:effectRef>
-          <a:fontRef idx="minor">
-            <a:schemeClr val="lt1"/>
-          </a:fontRef>
-        </p:style>
-        <p:txBody>
-          <a:bodyPr rtlCol="0" anchor="t" wrap="square" lIns="146304" rIns="146304" tIns="109728"/>
-          <a:lstStyle/>
-          <a:p>
-            <a:pPr algn="ctr"/>
-            <a:r>
-              <a:rPr sz="1650" b="1">
-                <a:solidFill>
-                  <a:srgbClr val="DC2626"/>
-                </a:solidFill>
-              </a:rPr>
-              <a:t>TRANSACTIONAL SAFETY</a:t>
-            </a:r>
-          </a:p>
-          <a:p>
-            <a:pPr algn="ctr">
-              <a:spcAft>
-                <a:spcPts val="400"/>
-              </a:spcAft>
-            </a:pPr>
-            <a:r>
-              <a:rPr sz="1450" b="1">
-                <a:solidFill>
-                  <a:srgbClr val="111827"/>
-                </a:solidFill>
-              </a:rPr>
-              <a:t>Zero duplicate state changes</a:t>
-            </a:r>
-          </a:p>
-          <a:p>
-            <a:pPr>
-              <a:spcBef>
-                <a:spcPts val="300"/>
-              </a:spcBef>
-            </a:pPr>
-            <a:r>
-              <a:rPr sz="1250" b="1">
-                <a:solidFill>
-                  <a:srgbClr val="111827"/>
-                </a:solidFill>
-              </a:rPr>
-              <a:t>• </a:t>
-            </a:r>
-            <a:r>
-              <a:rPr sz="1250">
-                <a:solidFill>
-                  <a:srgbClr val="475569"/>
-                </a:solidFill>
-              </a:rPr>
-              <a:t>Idempotency keys survive retries; tentative slots can never trigger a state change.</a:t>
-            </a:r>
-          </a:p>
-          <a:p>
-            <a:pPr>
-              <a:spcBef>
-                <a:spcPts val="300"/>
-              </a:spcBef>
-            </a:pPr>
-            <a:r>
-              <a:rPr sz="1250" b="1">
-                <a:solidFill>
-                  <a:srgbClr val="111827"/>
-                </a:solidFill>
-              </a:rPr>
-              <a:t>• </a:t>
-            </a:r>
-            <a:r>
-              <a:rPr sz="1250">
-                <a:solidFill>
-                  <a:srgbClr val="475569"/>
-                </a:solidFill>
-              </a:rPr>
-              <a:t>A commit that races a cancel is reconciled and reported — never repeated.</a:t>
-            </a:r>
-          </a:p>
-        </p:txBody>
-      </p:sp>
-      <p:sp>
-        <p:nvSpPr>
-          <p:cNvPr id="153" name="Rounded Rectangle 152"/>
-          <p:cNvSpPr/>
-          <p:nvPr/>
-        </p:nvSpPr>
-        <p:spPr>
-          <a:xfrm>
-            <a:off x="548640" y="4160520"/>
-            <a:ext cx="5440680" cy="2377440"/>
-          </a:xfrm>
-          <a:prstGeom prst="roundRect">
-            <a:avLst>
-              <a:gd name="adj" fmla="val 6000"/>
-            </a:avLst>
-          </a:prstGeom>
-          <a:solidFill>
-            <a:srgbClr val="F8F9FB"/>
-          </a:solidFill>
-          <a:ln w="19050">
-            <a:solidFill>
-              <a:srgbClr val="059669"/>
-            </a:solidFill>
-          </a:ln>
-          <a:effectLst/>
-        </p:spPr>
-        <p:style>
-          <a:lnRef idx="1">
-            <a:schemeClr val="accent1"/>
-          </a:lnRef>
-          <a:fillRef idx="3">
-            <a:schemeClr val="accent1"/>
-          </a:fillRef>
-          <a:effectRef idx="2">
-            <a:schemeClr val="accent1"/>
-          </a:effectRef>
-          <a:fontRef idx="minor">
-            <a:schemeClr val="lt1"/>
-          </a:fontRef>
-        </p:style>
-        <p:txBody>
-          <a:bodyPr rtlCol="0" anchor="t" wrap="square" lIns="146304" rIns="146304" tIns="109728"/>
-          <a:lstStyle/>
-          <a:p>
-            <a:pPr algn="ctr"/>
-            <a:r>
-              <a:rPr sz="1650" b="1">
-                <a:solidFill>
-                  <a:srgbClr val="059669"/>
-                </a:solidFill>
-              </a:rPr>
-              <a:t>LATENCY HIDING</a:t>
-            </a:r>
-          </a:p>
-          <a:p>
-            <a:pPr algn="ctr">
-              <a:spcAft>
-                <a:spcPts val="400"/>
-              </a:spcAft>
-            </a:pPr>
-            <a:r>
-              <a:rPr sz="1450" b="1">
-                <a:solidFill>
-                  <a:srgbClr val="111827"/>
-                </a:solidFill>
-              </a:rPr>
-              <a:t>Talk while tools work</a:t>
-            </a:r>
-          </a:p>
-          <a:p>
-            <a:pPr>
-              <a:spcBef>
-                <a:spcPts val="300"/>
-              </a:spcBef>
-            </a:pPr>
-            <a:r>
-              <a:rPr sz="1250" b="1">
-                <a:solidFill>
-                  <a:srgbClr val="111827"/>
-                </a:solidFill>
-              </a:rPr>
-              <a:t>• </a:t>
-            </a:r>
-            <a:r>
-              <a:rPr sz="1250">
-                <a:solidFill>
-                  <a:srgbClr val="475569"/>
-                </a:solidFill>
-              </a:rPr>
-              <a:t>Acknowledgments in 0.7 ms (median) vs 1.4 s for the half-duplex baseline.</a:t>
-            </a:r>
-          </a:p>
-          <a:p>
-            <a:pPr>
-              <a:spcBef>
-                <a:spcPts val="300"/>
-              </a:spcBef>
-            </a:pPr>
-            <a:r>
-              <a:rPr sz="1250" b="1">
-                <a:solidFill>
-                  <a:srgbClr val="111827"/>
-                </a:solidFill>
-              </a:rPr>
-              <a:t>• Speculative read-only prefetch from partial speech: </a:t>
-            </a:r>
-            <a:r>
-              <a:rPr sz="1250">
-                <a:solidFill>
-                  <a:srgbClr val="475569"/>
-                </a:solidFill>
-              </a:rPr>
-              <a:t>in T11 the answer is spoken at 1.90 s instead of 2.60 s (0.7 s saved).</a:t>
-            </a:r>
-          </a:p>
-        </p:txBody>
-      </p:sp>
-      <p:sp>
-        <p:nvSpPr>
-          <p:cNvPr id="154" name="Rounded Rectangle 153"/>
-          <p:cNvSpPr/>
-          <p:nvPr/>
-        </p:nvSpPr>
-        <p:spPr>
-          <a:xfrm>
-            <a:off x="6217920" y="4160520"/>
-            <a:ext cx="5440680" cy="2377440"/>
-          </a:xfrm>
-          <a:prstGeom prst="roundRect">
-            <a:avLst>
-              <a:gd name="adj" fmla="val 6000"/>
-            </a:avLst>
-          </a:prstGeom>
-          <a:solidFill>
-            <a:srgbClr val="F8F9FB"/>
-          </a:solidFill>
-          <a:ln w="19050">
-            <a:solidFill>
-              <a:srgbClr val="2563EB"/>
-            </a:solidFill>
-          </a:ln>
-          <a:effectLst/>
-        </p:spPr>
-        <p:style>
-          <a:lnRef idx="1">
-            <a:schemeClr val="accent1"/>
-          </a:lnRef>
-          <a:fillRef idx="3">
-            <a:schemeClr val="accent1"/>
-          </a:fillRef>
-          <a:effectRef idx="2">
-            <a:schemeClr val="accent1"/>
-          </a:effectRef>
-          <a:fontRef idx="minor">
-            <a:schemeClr val="lt1"/>
-          </a:fontRef>
-        </p:style>
-        <p:txBody>
-          <a:bodyPr rtlCol="0" anchor="t" wrap="square" lIns="146304" rIns="146304" tIns="109728"/>
-          <a:lstStyle/>
-          <a:p>
-            <a:pPr algn="ctr"/>
-            <a:r>
-              <a:rPr sz="1650" b="1">
-                <a:solidFill>
-                  <a:srgbClr val="2563EB"/>
-                </a:solidFill>
-              </a:rPr>
-              <a:t>MULTIMODAL</a:t>
-            </a:r>
-          </a:p>
-          <a:p>
-            <a:pPr algn="ctr">
-              <a:spcAft>
-                <a:spcPts val="400"/>
-              </a:spcAft>
-            </a:pPr>
-            <a:r>
-              <a:rPr sz="1450" b="1">
-                <a:solidFill>
-                  <a:srgbClr val="111827"/>
-                </a:solidFill>
-              </a:rPr>
-              <a:t>Speech + camera, with self-repair</a:t>
-            </a:r>
-          </a:p>
-          <a:p>
-            <a:pPr>
-              <a:spcBef>
-                <a:spcPts val="300"/>
-              </a:spcBef>
-            </a:pPr>
-            <a:r>
-              <a:rPr sz="1250" b="1">
-                <a:solidFill>
-                  <a:srgbClr val="111827"/>
-                </a:solidFill>
-              </a:rPr>
-              <a:t>• </a:t>
-            </a:r>
-            <a:r>
-              <a:rPr sz="1250">
-                <a:solidFill>
-                  <a:srgbClr val="475569"/>
-                </a:solidFill>
-              </a:rPr>
-              <a:t>OCR + LED grounding runs behind a spoken acknowledgment in a worker thread.</a:t>
-            </a:r>
-          </a:p>
-          <a:p>
-            <a:pPr>
-              <a:spcBef>
-                <a:spcPts val="300"/>
-              </a:spcBef>
-            </a:pPr>
-            <a:r>
-              <a:rPr sz="1250" b="1">
-                <a:solidFill>
-                  <a:srgbClr val="111827"/>
-                </a:solidFill>
-              </a:rPr>
-              <a:t>• </a:t>
-            </a:r>
-            <a:r>
-              <a:rPr sz="1250">
-                <a:solidFill>
-                  <a:srgbClr val="475569"/>
-                </a:solidFill>
-              </a:rPr>
-              <a:t>Cross-modal correction (error code → blinking light) cancels the stale lookup and re-grounds.</a:t>
-            </a:r>
-          </a:p>
-        </p:txBody>
-      </p:sp>
-    </p:spTree>
-  </p:cSld>
-  <p:clrMapOvr>
-    <a:masterClrMapping/>
-  </p:clrMapOvr>
-</p:sld>
-</file>
-
 <file path=ppt/slides/slide11.xml><?xml version="1.0" encoding="utf-8"?>
 <p:sld xmlns:a="http://schemas.openxmlformats.org/drawingml/2006/main" xmlns:r="http://schemas.openxmlformats.org/officeDocument/2006/relationships" xmlns:mc="http://schemas.openxmlformats.org/markup-compatibility/2006" xmlns:mv="urn:schemas-microsoft-com:mac:vml" xmlns:p="http://schemas.openxmlformats.org/presentationml/2006/main" xmlns:c="http://schemas.openxmlformats.org/drawingml/2006/chart" xmlns:dgm="http://schemas.openxmlformats.org/drawingml/2006/diagram" xmlns:o="urn:schemas-microsoft-com:office:office" xmlns:v="urn:schemas-microsoft-com:vml" xmlns:pvml="urn:schemas-microsoft-com:office:powerpoint" xmlns:com="http://schemas.openxmlformats.org/drawingml/2006/compatibility" xmlns:p14="http://schemas.microsoft.com/office/powerpoint/2010/main" xmlns:p15="http://schemas.microsoft.com/office/powerpoint/2012/main" xmlns:ahyp="http://schemas.microsoft.com/office/drawing/2018/hyperlinkcolor">
   <p:cSld>
@@ -14170,7 +13180,7 @@
                 <a:cs typeface="Calibri"/>
                 <a:sym typeface="Calibri"/>
               </a:rPr>
-              <a:t>Working prototype code — public or shared GitHub repo (Y/N): Y — code complete locally; GitHub link to be added after push</a:t>
+              <a:t>Working prototype code — public GitHub repo (Y/N): Y — github.com/Darsh-14/Audient</a:t>
             </a:r>
             <a:endParaRPr sz="2800"/>
           </a:p>
@@ -14201,7 +13211,7 @@
                 <a:cs typeface="Calibri"/>
                 <a:sym typeface="Calibri"/>
               </a:rPr>
-              <a:t>README with reproducible setup instructions (Y/N): Y — README.md, requirements.txt, run_evaluation.sh</a:t>
+              <a:t>README with reproducible setup instructions (Y/N): Y — README.md and fdb_agent/README.md (setup.sh, run_benchmark.sh)</a:t>
             </a:r>
             <a:endParaRPr sz="2800"/>
           </a:p>
@@ -14232,7 +13242,7 @@
                 <a:cs typeface="Calibri"/>
                 <a:sym typeface="Calibri"/>
               </a:rPr>
-              <a:t>Demo video, max 5 minutes (YouTube or Drive link): [to be recorded — link pending]</a:t>
+              <a:t>Demo video, 3 to 5 minutes (YouTube or Drive link): Google Drive folder, linked in README.md</a:t>
             </a:r>
             <a:endParaRPr sz="2800"/>
           </a:p>
@@ -14263,7 +13273,7 @@
                 <a:cs typeface="Calibri"/>
                 <a:sym typeface="Calibri"/>
               </a:rPr>
-              <a:t>Presentation file (PPT or PDF) (Y/N): Y — this deck</a:t>
+              <a:t>Presentation file (PPT or PDF) (Y/N): Y — this deck (8 slides)</a:t>
             </a:r>
             <a:endParaRPr sz="2800"/>
           </a:p>
@@ -14480,7 +13490,7 @@
                   <a:srgbClr val="475569"/>
                 </a:solidFill>
               </a:rPr>
-              <a:t>Repository: [GitHub link]   ·   Team: [Team Name], [College Name]</a:t>
+              <a:t>Repository: github.com/Darsh-14/Audient   ·   Team: [Team Name], [College Name]</a:t>
             </a:r>
           </a:p>
         </p:txBody>
@@ -15065,590 +14075,6 @@
                 </a:solidFill>
               </a:rPr>
               <a:t>abort superseded in-flight calls within a 15 ms grace period, update the state snapshot, never duplicate a state-changing action.</a:t>
-            </a:r>
-          </a:p>
-        </p:txBody>
-      </p:sp>
-    </p:spTree>
-  </p:cSld>
-  <p:clrMapOvr>
-    <a:masterClrMapping/>
-  </p:clrMapOvr>
-</p:sld>
-</file>
-
-<file path=ppt/slides/slide3.xml><?xml version="1.0" encoding="utf-8"?>
-<p:sld xmlns:a="http://schemas.openxmlformats.org/drawingml/2006/main" xmlns:r="http://schemas.openxmlformats.org/officeDocument/2006/relationships" xmlns:mc="http://schemas.openxmlformats.org/markup-compatibility/2006" xmlns:mv="urn:schemas-microsoft-com:mac:vml" xmlns:p="http://schemas.openxmlformats.org/presentationml/2006/main" xmlns:c="http://schemas.openxmlformats.org/drawingml/2006/chart" xmlns:dgm="http://schemas.openxmlformats.org/drawingml/2006/diagram" xmlns:o="urn:schemas-microsoft-com:office:office" xmlns:v="urn:schemas-microsoft-com:vml" xmlns:pvml="urn:schemas-microsoft-com:office:powerpoint" xmlns:com="http://schemas.openxmlformats.org/drawingml/2006/compatibility" xmlns:p14="http://schemas.microsoft.com/office/powerpoint/2010/main" xmlns:p15="http://schemas.microsoft.com/office/powerpoint/2012/main" xmlns:ahyp="http://schemas.microsoft.com/office/drawing/2018/hyperlinkcolor">
-  <p:cSld>
-    <p:spTree>
-      <p:nvGrpSpPr>
-        <p:cNvPr id="106" name="Shape 106"/>
-        <p:cNvGrpSpPr/>
-        <p:nvPr/>
-      </p:nvGrpSpPr>
-      <p:grpSpPr>
-        <a:xfrm>
-          <a:off x="0" y="0"/>
-          <a:ext cx="0" cy="0"/>
-          <a:chOff x="0" y="0"/>
-          <a:chExt cx="0" cy="0"/>
-        </a:xfrm>
-      </p:grpSpPr>
-      <p:sp>
-        <p:nvSpPr>
-          <p:cNvPr id="107" name="Google Shape;107;p3"/>
-          <p:cNvSpPr txBox="1"/>
-          <p:nvPr>
-            <p:ph type="title"/>
-          </p:nvPr>
-        </p:nvSpPr>
-        <p:spPr>
-          <a:xfrm>
-            <a:off x="548640" y="201168"/>
-            <a:ext cx="11064240" cy="868680"/>
-          </a:xfrm>
-          <a:prstGeom prst="rect">
-            <a:avLst/>
-          </a:prstGeom>
-          <a:noFill/>
-          <a:ln>
-            <a:noFill/>
-          </a:ln>
-        </p:spPr>
-        <p:txBody>
-          <a:bodyPr anchorCtr="0" anchor="ctr" bIns="45700" lIns="91425" spcFirstLastPara="1" rIns="91425" wrap="square" tIns="45700">
-            <a:normAutofit/>
-          </a:bodyPr>
-          <a:lstStyle/>
-          <a:p>
-            <a:pPr indent="0" lvl="0" marL="0" rtl="0" algn="l">
-              <a:lnSpc>
-                <a:spcPct val="90000"/>
-              </a:lnSpc>
-              <a:spcBef>
-                <a:spcPts val="0"/>
-              </a:spcBef>
-              <a:spcAft>
-                <a:spcPts val="0"/>
-              </a:spcAft>
-              <a:buClr>
-                <a:srgbClr val="704EA6"/>
-              </a:buClr>
-              <a:buSzPts val="4400"/>
-              <a:buFont typeface="Calibri"/>
-              <a:buNone/>
-            </a:pPr>
-            <a:r>
-              <a:rPr b="1" lang="en-US" sz="3800">
-                <a:solidFill>
-                  <a:srgbClr val="704EA6"/>
-                </a:solidFill>
-                <a:latin typeface="Calibri"/>
-                <a:ea typeface="Calibri"/>
-                <a:cs typeface="Calibri"/>
-                <a:sym typeface="Calibri"/>
-              </a:rPr>
-              <a:t>Existing Solutions &amp; Gaps</a:t>
-            </a:r>
-            <a:endParaRPr/>
-          </a:p>
-        </p:txBody>
-      </p:sp>
-      <p:sp>
-        <p:nvSpPr>
-          <p:cNvPr id="108" name="TextBox 107"/>
-          <p:cNvSpPr txBox="1"/>
-          <p:nvPr/>
-        </p:nvSpPr>
-        <p:spPr>
-          <a:xfrm>
-            <a:off x="566928" y="1051560"/>
-            <a:ext cx="11064240" cy="411480"/>
-          </a:xfrm>
-          <a:prstGeom prst="rect">
-            <a:avLst/>
-          </a:prstGeom>
-          <a:noFill/>
-        </p:spPr>
-        <p:txBody>
-          <a:bodyPr wrap="square">
-            <a:spAutoFit/>
-          </a:bodyPr>
-          <a:lstStyle/>
-          <a:p>
-            <a:r>
-              <a:rPr sz="1500" b="1">
-                <a:solidFill>
-                  <a:srgbClr val="6D28D9"/>
-                </a:solidFill>
-              </a:rPr>
-              <a:t>Why current assistant architectures break under interruption</a:t>
-            </a:r>
-          </a:p>
-        </p:txBody>
-      </p:sp>
-      <p:sp>
-        <p:nvSpPr>
-          <p:cNvPr id="109" name="Rounded Rectangle 108"/>
-          <p:cNvSpPr/>
-          <p:nvPr/>
-        </p:nvSpPr>
-        <p:spPr>
-          <a:xfrm>
-            <a:off x="548640" y="1645920"/>
-            <a:ext cx="3611880" cy="4892040"/>
-          </a:xfrm>
-          <a:prstGeom prst="roundRect">
-            <a:avLst>
-              <a:gd name="adj" fmla="val 6000"/>
-            </a:avLst>
-          </a:prstGeom>
-          <a:solidFill>
-            <a:srgbClr val="F8F9FB"/>
-          </a:solidFill>
-          <a:ln w="19050">
-            <a:solidFill>
-              <a:srgbClr val="059669"/>
-            </a:solidFill>
-          </a:ln>
-          <a:effectLst/>
-        </p:spPr>
-        <p:style>
-          <a:lnRef idx="1">
-            <a:schemeClr val="accent1"/>
-          </a:lnRef>
-          <a:fillRef idx="3">
-            <a:schemeClr val="accent1"/>
-          </a:fillRef>
-          <a:effectRef idx="2">
-            <a:schemeClr val="accent1"/>
-          </a:effectRef>
-          <a:fontRef idx="minor">
-            <a:schemeClr val="lt1"/>
-          </a:fontRef>
-        </p:style>
-        <p:txBody>
-          <a:bodyPr rtlCol="0" anchor="t" wrap="square" lIns="146304" rIns="146304" tIns="109728"/>
-          <a:lstStyle/>
-          <a:p>
-            <a:pPr algn="ctr"/>
-            <a:r>
-              <a:rPr sz="1650" b="1">
-                <a:solidFill>
-                  <a:srgbClr val="059669"/>
-                </a:solidFill>
-              </a:rPr>
-              <a:t>CASCADED PIPELINE</a:t>
-            </a:r>
-          </a:p>
-          <a:p>
-            <a:pPr algn="ctr">
-              <a:spcAft>
-                <a:spcPts val="400"/>
-              </a:spcAft>
-            </a:pPr>
-            <a:r>
-              <a:rPr sz="1450" b="1">
-                <a:solidFill>
-                  <a:srgbClr val="111827"/>
-                </a:solidFill>
-              </a:rPr>
-              <a:t>ASR → LLM → TTS, turn by turn</a:t>
-            </a:r>
-          </a:p>
-          <a:p>
-            <a:pPr>
-              <a:spcBef>
-                <a:spcPts val="300"/>
-              </a:spcBef>
-            </a:pPr>
-            <a:r>
-              <a:rPr sz="1250" b="1">
-                <a:solidFill>
-                  <a:srgbClr val="111827"/>
-                </a:solidFill>
-              </a:rPr>
-              <a:t>• Strength: </a:t>
-            </a:r>
-            <a:r>
-              <a:rPr sz="1250">
-                <a:solidFill>
-                  <a:srgbClr val="475569"/>
-                </a:solidFill>
-              </a:rPr>
-              <a:t>mature, modular, strong language quality on clean single turns.</a:t>
-            </a:r>
-          </a:p>
-          <a:p>
-            <a:pPr>
-              <a:spcBef>
-                <a:spcPts val="300"/>
-              </a:spcBef>
-            </a:pPr>
-            <a:r>
-              <a:rPr sz="1250" b="1">
-                <a:solidFill>
-                  <a:srgbClr val="111827"/>
-                </a:solidFill>
-              </a:rPr>
-              <a:t>• Gap: </a:t>
-            </a:r>
-            <a:r>
-              <a:rPr sz="1250">
-                <a:solidFill>
-                  <a:srgbClr val="475569"/>
-                </a:solidFill>
-              </a:rPr>
-              <a:t>latency adds up stage by stage; the user hears nothing until the tool returns.</a:t>
-            </a:r>
-          </a:p>
-          <a:p>
-            <a:pPr>
-              <a:spcBef>
-                <a:spcPts val="300"/>
-              </a:spcBef>
-            </a:pPr>
-            <a:r>
-              <a:rPr sz="1250" b="1">
-                <a:solidFill>
-                  <a:srgbClr val="111827"/>
-                </a:solidFill>
-              </a:rPr>
-              <a:t>• Gap: </a:t>
-            </a:r>
-            <a:r>
-              <a:rPr sz="1250">
-                <a:solidFill>
-                  <a:srgbClr val="475569"/>
-                </a:solidFill>
-              </a:rPr>
-              <a:t>no transactional rollback — a mid-flight correction is handled only after the stale call completes.</a:t>
-            </a:r>
-          </a:p>
-          <a:p>
-            <a:pPr>
-              <a:spcBef>
-                <a:spcPts val="300"/>
-              </a:spcBef>
-            </a:pPr>
-            <a:r>
-              <a:rPr sz="1250" b="1">
-                <a:solidFill>
-                  <a:srgbClr val="111827"/>
-                </a:solidFill>
-              </a:rPr>
-              <a:t>• Measured (our half-duplex baseline, same NLU &amp; OCR): </a:t>
-            </a:r>
-            <a:r>
-              <a:rPr sz="1250">
-                <a:solidFill>
-                  <a:srgbClr val="475569"/>
-                </a:solidFill>
-              </a:rPr>
-              <a:t>median first response 1.4 s, max 3.4 s; 1/15 scenarios fully correct.</a:t>
-            </a:r>
-          </a:p>
-        </p:txBody>
-      </p:sp>
-      <p:sp>
-        <p:nvSpPr>
-          <p:cNvPr id="110" name="Rounded Rectangle 109"/>
-          <p:cNvSpPr/>
-          <p:nvPr/>
-        </p:nvSpPr>
-        <p:spPr>
-          <a:xfrm>
-            <a:off x="4297680" y="1645920"/>
-            <a:ext cx="3611880" cy="4892040"/>
-          </a:xfrm>
-          <a:prstGeom prst="roundRect">
-            <a:avLst>
-              <a:gd name="adj" fmla="val 6000"/>
-            </a:avLst>
-          </a:prstGeom>
-          <a:solidFill>
-            <a:srgbClr val="F8F9FB"/>
-          </a:solidFill>
-          <a:ln w="19050">
-            <a:solidFill>
-              <a:srgbClr val="2563EB"/>
-            </a:solidFill>
-          </a:ln>
-          <a:effectLst/>
-        </p:spPr>
-        <p:style>
-          <a:lnRef idx="1">
-            <a:schemeClr val="accent1"/>
-          </a:lnRef>
-          <a:fillRef idx="3">
-            <a:schemeClr val="accent1"/>
-          </a:fillRef>
-          <a:effectRef idx="2">
-            <a:schemeClr val="accent1"/>
-          </a:effectRef>
-          <a:fontRef idx="minor">
-            <a:schemeClr val="lt1"/>
-          </a:fontRef>
-        </p:style>
-        <p:txBody>
-          <a:bodyPr rtlCol="0" anchor="t" wrap="square" lIns="146304" rIns="146304" tIns="109728"/>
-          <a:lstStyle/>
-          <a:p>
-            <a:pPr algn="ctr"/>
-            <a:r>
-              <a:rPr sz="1650" b="1">
-                <a:solidFill>
-                  <a:srgbClr val="2563EB"/>
-                </a:solidFill>
-              </a:rPr>
-              <a:t>END-TO-END SPEECH MODELS</a:t>
-            </a:r>
-          </a:p>
-          <a:p>
-            <a:pPr algn="ctr">
-              <a:spcAft>
-                <a:spcPts val="400"/>
-              </a:spcAft>
-            </a:pPr>
-            <a:r>
-              <a:rPr sz="1450" b="1">
-                <a:solidFill>
-                  <a:srgbClr val="111827"/>
-                </a:solidFill>
-              </a:rPr>
-              <a:t>Single audio-in / audio-out network</a:t>
-            </a:r>
-          </a:p>
-          <a:p>
-            <a:pPr>
-              <a:spcBef>
-                <a:spcPts val="300"/>
-              </a:spcBef>
-            </a:pPr>
-            <a:r>
-              <a:rPr sz="1250" b="1">
-                <a:solidFill>
-                  <a:srgbClr val="111827"/>
-                </a:solidFill>
-              </a:rPr>
-              <a:t>• Strength: </a:t>
-            </a:r>
-            <a:r>
-              <a:rPr sz="1250">
-                <a:solidFill>
-                  <a:srgbClr val="475569"/>
-                </a:solidFill>
-              </a:rPr>
-              <a:t>fast, natural turn-taking and prosody.</a:t>
-            </a:r>
-          </a:p>
-          <a:p>
-            <a:pPr>
-              <a:spcBef>
-                <a:spcPts val="300"/>
-              </a:spcBef>
-            </a:pPr>
-            <a:r>
-              <a:rPr sz="1250" b="1">
-                <a:solidFill>
-                  <a:srgbClr val="111827"/>
-                </a:solidFill>
-              </a:rPr>
-              <a:t>• Gap: </a:t>
-            </a:r>
-            <a:r>
-              <a:rPr sz="1250">
-                <a:solidFill>
-                  <a:srgbClr val="475569"/>
-                </a:solidFill>
-              </a:rPr>
-              <a:t>tool calls and dialogue state live inside the model — hard to cancel, audit or make idempotent.</a:t>
-            </a:r>
-          </a:p>
-          <a:p>
-            <a:pPr>
-              <a:spcBef>
-                <a:spcPts val="300"/>
-              </a:spcBef>
-            </a:pPr>
-            <a:r>
-              <a:rPr sz="1250" b="1">
-                <a:solidFill>
-                  <a:srgbClr val="111827"/>
-                </a:solidFill>
-              </a:rPr>
-              <a:t>• Gap: </a:t>
-            </a:r>
-            <a:r>
-              <a:rPr sz="1250">
-                <a:solidFill>
-                  <a:srgbClr val="475569"/>
-                </a:solidFill>
-              </a:rPr>
-              <a:t>risk of acting on early parameters before the user finishes, and of stale slot values leaking into chained calls.</a:t>
-            </a:r>
-          </a:p>
-        </p:txBody>
-      </p:sp>
-      <p:sp>
-        <p:nvSpPr>
-          <p:cNvPr id="111" name="Rounded Rectangle 110"/>
-          <p:cNvSpPr/>
-          <p:nvPr/>
-        </p:nvSpPr>
-        <p:spPr>
-          <a:xfrm>
-            <a:off x="8046720" y="1645920"/>
-            <a:ext cx="3611880" cy="4892040"/>
-          </a:xfrm>
-          <a:prstGeom prst="roundRect">
-            <a:avLst>
-              <a:gd name="adj" fmla="val 6000"/>
-            </a:avLst>
-          </a:prstGeom>
-          <a:solidFill>
-            <a:srgbClr val="F8F9FB"/>
-          </a:solidFill>
-          <a:ln w="19050">
-            <a:solidFill>
-              <a:srgbClr val="6D28D9"/>
-            </a:solidFill>
-          </a:ln>
-          <a:effectLst/>
-        </p:spPr>
-        <p:style>
-          <a:lnRef idx="1">
-            <a:schemeClr val="accent1"/>
-          </a:lnRef>
-          <a:fillRef idx="3">
-            <a:schemeClr val="accent1"/>
-          </a:fillRef>
-          <a:effectRef idx="2">
-            <a:schemeClr val="accent1"/>
-          </a:effectRef>
-          <a:fontRef idx="minor">
-            <a:schemeClr val="lt1"/>
-          </a:fontRef>
-        </p:style>
-        <p:txBody>
-          <a:bodyPr rtlCol="0" anchor="t" wrap="square" lIns="146304" rIns="146304" tIns="109728"/>
-          <a:lstStyle/>
-          <a:p>
-            <a:pPr algn="ctr"/>
-            <a:r>
-              <a:rPr sz="1650" b="1">
-                <a:solidFill>
-                  <a:srgbClr val="6D28D9"/>
-                </a:solidFill>
-              </a:rPr>
-              <a:t>GAPS WE CLOSE</a:t>
-            </a:r>
-          </a:p>
-          <a:p>
-            <a:pPr algn="ctr">
-              <a:spcAft>
-                <a:spcPts val="400"/>
-              </a:spcAft>
-            </a:pPr>
-            <a:r>
-              <a:rPr sz="1450" b="1">
-                <a:solidFill>
-                  <a:srgbClr val="111827"/>
-                </a:solidFill>
-              </a:rPr>
-              <a:t>Three unresolved problems</a:t>
-            </a:r>
-          </a:p>
-          <a:p>
-            <a:pPr>
-              <a:spcBef>
-                <a:spcPts val="300"/>
-              </a:spcBef>
-            </a:pPr>
-            <a:r>
-              <a:rPr sz="1250" b="1">
-                <a:solidFill>
-                  <a:srgbClr val="111827"/>
-                </a:solidFill>
-              </a:rPr>
-              <a:t>• Stale &amp; duplicate execution: </a:t>
-            </a:r>
-            <a:r>
-              <a:rPr sz="1250">
-                <a:solidFill>
-                  <a:srgbClr val="475569"/>
-                </a:solidFill>
-              </a:rPr>
-              <a:t>no cancellation graph → wrong or double bookings.</a:t>
-            </a:r>
-          </a:p>
-          <a:p>
-            <a:pPr>
-              <a:spcBef>
-                <a:spcPts val="300"/>
-              </a:spcBef>
-            </a:pPr>
-            <a:r>
-              <a:rPr sz="1250" b="1">
-                <a:solidFill>
-                  <a:srgbClr val="111827"/>
-                </a:solidFill>
-              </a:rPr>
-              <a:t>• Dead air vs. hallucinated completion: </a:t>
-            </a:r>
-            <a:r>
-              <a:rPr sz="1250">
-                <a:solidFill>
-                  <a:srgbClr val="475569"/>
-                </a:solidFill>
-              </a:rPr>
-              <a:t>either silence while tools run, or 'Done!' before they finish.</a:t>
-            </a:r>
-          </a:p>
-          <a:p>
-            <a:pPr>
-              <a:spcBef>
-                <a:spcPts val="300"/>
-              </a:spcBef>
-            </a:pPr>
-            <a:r>
-              <a:rPr sz="1250" b="1">
-                <a:solidFill>
-                  <a:srgbClr val="111827"/>
-                </a:solidFill>
-              </a:rPr>
-              <a:t>• Fragile floor arbitration: </a:t>
-            </a:r>
-            <a:r>
-              <a:rPr sz="1250">
-                <a:solidFill>
-                  <a:srgbClr val="475569"/>
-                </a:solidFill>
-              </a:rPr>
-              <a:t>pauses and fillers mistaken for end of turn; real interruptions ignored.</a:t>
-            </a:r>
-          </a:p>
-          <a:p>
-            <a:pPr>
-              <a:spcBef>
-                <a:spcPts val="300"/>
-              </a:spcBef>
-            </a:pPr>
-            <a:r>
-              <a:rPr sz="1250" b="1">
-                <a:solidFill>
-                  <a:srgbClr val="111827"/>
-                </a:solidFill>
-              </a:rPr>
-              <a:t>• Our baseline shows it: </a:t>
-            </a:r>
-            <a:r>
-              <a:rPr sz="1250">
-                <a:solidFill>
-                  <a:srgbClr val="475569"/>
-                </a:solidFill>
-              </a:rPr>
-              <a:t>1 double booking and 31% of interruption checks failed.</a:t>
             </a:r>
           </a:p>
         </p:txBody>
@@ -15773,7 +14199,7 @@
                   <a:srgbClr val="6D28D9"/>
                 </a:solidFill>
               </a:rPr>
-              <a:t>Audient: dual-path engine with a dynamic cancellation graph and transactional state</a:t>
+              <a:t>Audient on Full-Duplex-Bench v3: Gemini Live through LiveKit, with a coordination layer between model and tools</a:t>
             </a:r>
           </a:p>
         </p:txBody>
@@ -15829,7 +14255,7 @@
                   <a:srgbClr val="111827"/>
                 </a:solidFill>
               </a:rPr>
-              <a:t>Event inbox (timestamped)</a:t>
+              <a:t>User audio → LiveKit room</a:t>
             </a:r>
           </a:p>
           <a:p>
@@ -15840,7 +14266,7 @@
                   <a:srgbClr val="475569"/>
                 </a:solidFill>
               </a:rPr>
-              <a:t>transcript chunks · WAV · PNG frames · interruptions · tool results · manifests</a:t>
+              <a:t>FDB-v3 recording (48 kHz, fillers, pauses, self-corrections), streamed live</a:t>
             </a:r>
           </a:p>
         </p:txBody>
@@ -15896,7 +14322,7 @@
                   <a:srgbClr val="059669"/>
                 </a:solidFill>
               </a:rPr>
-              <a:t>FAST PATH (sync, never awaits)</a:t>
+              <a:t>LOCAL VOICE DETECTOR</a:t>
             </a:r>
           </a:p>
           <a:p>
@@ -15907,7 +14333,7 @@
                   <a:srgbClr val="475569"/>
                 </a:solidFill>
               </a:rPr>
-              <a:t>disfluency normaliser · semantic</a:t>
+              <a:t>Silero VAD on the user's audio:</a:t>
             </a:r>
           </a:p>
           <a:p>
@@ -15918,7 +14344,7 @@
                   <a:srgbClr val="475569"/>
                 </a:solidFill>
               </a:rPr>
-              <a:t>end-of-turn check · self-repair ·</a:t>
+              <a:t>when the user starts and</a:t>
             </a:r>
           </a:p>
           <a:p>
@@ -15929,7 +14355,7 @@
                   <a:srgbClr val="475569"/>
                 </a:solidFill>
               </a:rPr>
-              <a:t>conflict detection · spoken acks</a:t>
+              <a:t>stops speaking</a:t>
             </a:r>
           </a:p>
         </p:txBody>
@@ -15985,7 +14411,7 @@
                   <a:srgbClr val="2563EB"/>
                 </a:solidFill>
               </a:rPr>
-              <a:t>SLOW PATH (async tasks)</a:t>
+              <a:t>GEMINI LIVE</a:t>
             </a:r>
           </a:p>
           <a:p>
@@ -15996,7 +14422,7 @@
                   <a:srgbClr val="475569"/>
                 </a:solidFill>
               </a:rPr>
-              <a:t>schema-driven planner · chained &amp;</a:t>
+              <a:t>Gemini 2.5 Flash native audio:</a:t>
             </a:r>
           </a:p>
           <a:p>
@@ -16007,7 +14433,7 @@
                   <a:srgbClr val="475569"/>
                 </a:solidFill>
               </a:rPr>
-              <a:t>retried tool calls · OCR / LED /</a:t>
+              <a:t>listens, decides, speaks,</a:t>
             </a:r>
           </a:p>
           <a:p>
@@ -16018,7 +14444,7 @@
                   <a:srgbClr val="475569"/>
                 </a:solidFill>
               </a:rPr>
-              <a:t>Whisper in worker threads</a:t>
+              <a:t>issues tool calls</a:t>
             </a:r>
           </a:p>
         </p:txBody>
@@ -16074,7 +14500,7 @@
                   <a:srgbClr val="DC2626"/>
                 </a:solidFill>
               </a:rPr>
-              <a:t>COORDINATION LAYER</a:t>
+              <a:t>AUDIENT COORDINATION LAYER</a:t>
             </a:r>
           </a:p>
           <a:p>
@@ -16085,7 +14511,7 @@
                   <a:srgbClr val="475569"/>
                 </a:solidFill>
               </a:rPr>
-              <a:t>cancellation graph (DAG) · two-tier slots: tentative | committed</a:t>
+              <a:t>hold, then commit (2.0 s of quiet) · defer, don't drop</a:t>
             </a:r>
           </a:p>
           <a:p>
@@ -16096,7 +14522,7 @@
                   <a:srgbClr val="475569"/>
                 </a:solidFill>
               </a:rPr>
-              <a:t>SHA-256 idempotency keys · commit ledger · retry with same key</a:t>
+              <a:t>never repeat an identical call · ask for the reply if Gemini drops it</a:t>
             </a:r>
           </a:p>
         </p:txBody>
@@ -16152,7 +14578,7 @@
                   <a:srgbClr val="111827"/>
                 </a:solidFill>
               </a:rPr>
-              <a:t>Action outbox</a:t>
+              <a:t>FDB-v3 mock tools and call log</a:t>
             </a:r>
           </a:p>
           <a:p>
@@ -16163,7 +14589,7 @@
                   <a:srgbClr val="475569"/>
                 </a:solidFill>
               </a:rPr>
-              <a:t>speak (ack / progress / filler) · tool_call(call_id) · cancel · clarify · final_response + state snapshot</a:t>
+              <a:t>12 tools in 4 domains (travel, finance, housing, e-commerce), scored by FDB-v3</a:t>
             </a:r>
           </a:p>
         </p:txBody>
@@ -16248,8 +14674,8 @@
         </p:nvCxnSpPr>
         <p:spPr>
           <a:xfrm>
-            <a:off x="3154680" y="3172968"/>
-            <a:ext cx="182880" cy="0"/>
+            <a:off x="1828800" y="3794760"/>
+            <a:ext cx="0" cy="320040"/>
           </a:xfrm>
           <a:prstGeom prst="line">
             <a:avLst/>
@@ -16284,7 +14710,7 @@
         </p:nvCxnSpPr>
         <p:spPr>
           <a:xfrm>
-            <a:off x="1828800" y="3794760"/>
+            <a:off x="4663440" y="3794760"/>
             <a:ext cx="0" cy="320040"/>
           </a:xfrm>
           <a:prstGeom prst="line">
@@ -16320,42 +14746,6 @@
         </p:nvCxnSpPr>
         <p:spPr>
           <a:xfrm>
-            <a:off x="4663440" y="3794760"/>
-            <a:ext cx="0" cy="320040"/>
-          </a:xfrm>
-          <a:prstGeom prst="line">
-            <a:avLst/>
-          </a:prstGeom>
-          <a:ln w="22225">
-            <a:solidFill>
-              <a:srgbClr val="475569"/>
-            </a:solidFill>
-            <a:tailEnd type="triangle"/>
-          </a:ln>
-        </p:spPr>
-        <p:style>
-          <a:lnRef idx="2">
-            <a:schemeClr val="accent1"/>
-          </a:lnRef>
-          <a:fillRef idx="0">
-            <a:schemeClr val="accent1"/>
-          </a:fillRef>
-          <a:effectRef idx="1">
-            <a:schemeClr val="accent1"/>
-          </a:effectRef>
-          <a:fontRef idx="minor">
-            <a:schemeClr val="tx1"/>
-          </a:fontRef>
-        </p:style>
-      </p:cxnSp>
-      <p:cxnSp>
-        <p:nvCxnSpPr>
-          <p:cNvPr id="125" name="Connector 124"/>
-          <p:cNvCxnSpPr/>
-          <p:nvPr/>
-        </p:nvCxnSpPr>
-        <p:spPr>
-          <a:xfrm>
             <a:off x="3246120" y="5212080"/>
             <a:ext cx="0" cy="320040"/>
           </a:xfrm>
@@ -16386,7 +14776,7 @@
       </p:cxnSp>
       <p:sp>
         <p:nvSpPr>
-          <p:cNvPr id="126" name="Rounded Rectangle 125"/>
+          <p:cNvPr id="125" name="Rounded Rectangle 124"/>
           <p:cNvSpPr/>
           <p:nvPr/>
         </p:nvSpPr>
@@ -16435,7 +14825,7 @@
                   <a:srgbClr val="059669"/>
                 </a:solidFill>
               </a:rPr>
-              <a:t>REFLEX PATH</a:t>
+              <a:t>HOLD, THEN COMMIT</a:t>
             </a:r>
           </a:p>
           <a:p>
@@ -16450,7 +14840,7 @@
                   <a:srgbClr val="111827"/>
                 </a:solidFill>
               </a:rPr>
-              <a:t>• Semantic acknowledgments ('Got it, updating that. Booking flight for 3.'): </a:t>
+              <a:t>• Pauses: </a:t>
             </a:r>
             <a:r>
               <a:rPr sz="1050">
@@ -16458,7 +14848,7 @@
                   <a:srgbClr val="475569"/>
                 </a:solidFill>
               </a:rPr>
-              <a:t>median 0.7 ms, max 5.3 ms after the user's turn ends.</a:t>
+              <a:t>a call made in a pause mid-sentence waits until the user has been quiet for 2.0 s (pauses in FDB-v3 last 1.6-3.2 s).</a:t>
             </a:r>
           </a:p>
           <a:p>
@@ -16473,7 +14863,7 @@
                   <a:srgbClr val="111827"/>
                 </a:solidFill>
               </a:rPr>
-              <a:t>• </a:t>
+              <a:t>• Quiet: </a:t>
             </a:r>
             <a:r>
               <a:rPr sz="1050">
@@ -16481,14 +14871,14 @@
                   <a:srgbClr val="475569"/>
                 </a:solidFill>
               </a:rPr>
-              <a:t>Progress narration only after 2.5 s of silence; never claims completion before a tool result.</a:t>
+              <a:t>measured on the user's own audio; LiveKit's Gemini plugin reports Gemini's replies as user speech.</a:t>
             </a:r>
           </a:p>
         </p:txBody>
       </p:sp>
       <p:sp>
         <p:nvSpPr>
-          <p:cNvPr id="127" name="Rounded Rectangle 126"/>
+          <p:cNvPr id="126" name="Rounded Rectangle 125"/>
           <p:cNvSpPr/>
           <p:nvPr/>
         </p:nvSpPr>
@@ -16537,7 +14927,7 @@
                   <a:srgbClr val="DC2626"/>
                 </a:solidFill>
               </a:rPr>
-              <a:t>CANCELLATION GRAPH</a:t>
+              <a:t>DEFER, DON'T DROP</a:t>
             </a:r>
           </a:p>
           <a:p>
@@ -16552,7 +14942,7 @@
                   <a:srgbClr val="111827"/>
                 </a:solidFill>
               </a:rPr>
-              <a:t>• Every call, retry timer and progress timer is a DAG node; invalidating a call kills its descendants. Measured cancel latency after a correction: </a:t>
+              <a:t>• Talked over: </a:t>
             </a:r>
             <a:r>
               <a:rPr sz="1050">
@@ -16560,7 +14950,7 @@
                   <a:srgbClr val="475569"/>
                 </a:solidFill>
               </a:rPr>
-              <a:t>max 4.5 ms (grace 15 ms).</a:t>
+              <a:t>if the user speaks again, the call waits; it is dropped only after a correction ('wait', 'actually') and a newer call to the same tool.</a:t>
             </a:r>
           </a:p>
           <a:p>
@@ -16575,7 +14965,7 @@
                   <a:srgbClr val="111827"/>
                 </a:solidFill>
               </a:rPr>
-              <a:t>• </a:t>
+              <a:t>• Result: </a:t>
             </a:r>
             <a:r>
               <a:rPr sz="1050">
@@ -16583,14 +14973,14 @@
                   <a:srgbClr val="475569"/>
                 </a:solidFill>
               </a:rPr>
-              <a:t>Mid-utterance repair cues ('no wait', 'actually', 'make it') trigger cancellation from partial transcripts.</a:t>
+              <a:t>self-corrections pass 70.6% vs 41.2% for FDB-v3's own Gemini agent.</a:t>
             </a:r>
           </a:p>
         </p:txBody>
       </p:sp>
       <p:sp>
         <p:nvSpPr>
-          <p:cNvPr id="128" name="Rounded Rectangle 127"/>
+          <p:cNvPr id="127" name="Rounded Rectangle 126"/>
           <p:cNvSpPr/>
           <p:nvPr/>
         </p:nvSpPr>
@@ -16639,7 +15029,7 @@
                   <a:srgbClr val="6D28D9"/>
                 </a:solidFill>
               </a:rPr>
-              <a:t>TRANSACTIONAL SAFETY</a:t>
+              <a:t>NEVER REPEAT, NEVER SILENT</a:t>
             </a:r>
           </a:p>
           <a:p>
@@ -16654,7 +15044,7 @@
                   <a:srgbClr val="111827"/>
                 </a:solidFill>
               </a:rPr>
-              <a:t>• </a:t>
+              <a:t>• Idempotent: </a:t>
             </a:r>
             <a:r>
               <a:rPr sz="1050">
@@ -16662,7 +15052,7 @@
                   <a:srgbClr val="475569"/>
                 </a:solidFill>
               </a:rPr>
-              <a:t>Tentative slots from partial speech never reach a state-changing call; only committed slots do.</a:t>
+              <a:t>a call with the same tool and arguments runs once; its result is reused.</a:t>
             </a:r>
           </a:p>
           <a:p>
@@ -16677,7 +15067,7 @@
                   <a:srgbClr val="111827"/>
                 </a:solidFill>
               </a:rPr>
-              <a:t>• </a:t>
+              <a:t>• Reply guard: </a:t>
             </a:r>
             <a:r>
               <a:rPr sz="1050">
@@ -16685,1092 +15075,7 @@
                   <a:srgbClr val="475569"/>
                 </a:solidFill>
               </a:rPr>
-              <a:t>SHA-256 key over tool + canonical args; commit ledger blocks repeats; a late commit after a cancel is detected and reported, not duplicated.</a:t>
-            </a:r>
-          </a:p>
-        </p:txBody>
-      </p:sp>
-    </p:spTree>
-  </p:cSld>
-  <p:clrMapOvr>
-    <a:masterClrMapping/>
-  </p:clrMapOvr>
-</p:sld>
-</file>
-
-<file path=ppt/slides/slide5.xml><?xml version="1.0" encoding="utf-8"?>
-<p:sld xmlns:a="http://schemas.openxmlformats.org/drawingml/2006/main" xmlns:r="http://schemas.openxmlformats.org/officeDocument/2006/relationships" xmlns:mc="http://schemas.openxmlformats.org/markup-compatibility/2006" xmlns:mv="urn:schemas-microsoft-com:mac:vml" xmlns:p="http://schemas.openxmlformats.org/presentationml/2006/main" xmlns:c="http://schemas.openxmlformats.org/drawingml/2006/chart" xmlns:dgm="http://schemas.openxmlformats.org/drawingml/2006/diagram" xmlns:o="urn:schemas-microsoft-com:office:office" xmlns:v="urn:schemas-microsoft-com:vml" xmlns:pvml="urn:schemas-microsoft-com:office:powerpoint" xmlns:com="http://schemas.openxmlformats.org/drawingml/2006/compatibility" xmlns:p14="http://schemas.microsoft.com/office/powerpoint/2010/main" xmlns:p15="http://schemas.microsoft.com/office/powerpoint/2012/main" xmlns:ahyp="http://schemas.microsoft.com/office/drawing/2018/hyperlinkcolor">
-  <p:cSld>
-    <p:spTree>
-      <p:nvGrpSpPr>
-        <p:cNvPr id="118" name="Shape 118"/>
-        <p:cNvGrpSpPr/>
-        <p:nvPr/>
-      </p:nvGrpSpPr>
-      <p:grpSpPr>
-        <a:xfrm>
-          <a:off x="0" y="0"/>
-          <a:ext cx="0" cy="0"/>
-          <a:chOff x="0" y="0"/>
-          <a:chExt cx="0" cy="0"/>
-        </a:xfrm>
-      </p:grpSpPr>
-      <p:sp>
-        <p:nvSpPr>
-          <p:cNvPr id="119" name="Google Shape;119;p5"/>
-          <p:cNvSpPr txBox="1"/>
-          <p:nvPr>
-            <p:ph type="title"/>
-          </p:nvPr>
-        </p:nvSpPr>
-        <p:spPr>
-          <a:xfrm>
-            <a:off x="548640" y="201168"/>
-            <a:ext cx="11064240" cy="868680"/>
-          </a:xfrm>
-          <a:prstGeom prst="rect">
-            <a:avLst/>
-          </a:prstGeom>
-          <a:noFill/>
-          <a:ln>
-            <a:noFill/>
-          </a:ln>
-        </p:spPr>
-        <p:txBody>
-          <a:bodyPr anchorCtr="0" anchor="ctr" bIns="45700" lIns="91425" spcFirstLastPara="1" rIns="91425" wrap="square" tIns="45700">
-            <a:normAutofit/>
-          </a:bodyPr>
-          <a:lstStyle/>
-          <a:p>
-            <a:pPr indent="0" lvl="0" marL="0" rtl="0" algn="l">
-              <a:lnSpc>
-                <a:spcPct val="90000"/>
-              </a:lnSpc>
-              <a:spcBef>
-                <a:spcPts val="0"/>
-              </a:spcBef>
-              <a:spcAft>
-                <a:spcPts val="0"/>
-              </a:spcAft>
-              <a:buClr>
-                <a:srgbClr val="704EA6"/>
-              </a:buClr>
-              <a:buSzPts val="4400"/>
-              <a:buFont typeface="Calibri"/>
-              <a:buNone/>
-            </a:pPr>
-            <a:r>
-              <a:rPr b="1" lang="en-US" sz="3800">
-                <a:solidFill>
-                  <a:srgbClr val="704EA6"/>
-                </a:solidFill>
-                <a:latin typeface="Calibri"/>
-                <a:ea typeface="Calibri"/>
-                <a:cs typeface="Calibri"/>
-                <a:sym typeface="Calibri"/>
-              </a:rPr>
-              <a:t>Demo &amp; Product Walkthrough</a:t>
-            </a:r>
-            <a:endParaRPr/>
-          </a:p>
-        </p:txBody>
-      </p:sp>
-      <p:sp>
-        <p:nvSpPr>
-          <p:cNvPr id="120" name="TextBox 119"/>
-          <p:cNvSpPr txBox="1"/>
-          <p:nvPr/>
-        </p:nvSpPr>
-        <p:spPr>
-          <a:xfrm>
-            <a:off x="566928" y="1051560"/>
-            <a:ext cx="11064240" cy="411480"/>
-          </a:xfrm>
-          <a:prstGeom prst="rect">
-            <a:avLst/>
-          </a:prstGeom>
-          <a:noFill/>
-        </p:spPr>
-        <p:txBody>
-          <a:bodyPr wrap="square">
-            <a:spAutoFit/>
-          </a:bodyPr>
-          <a:lstStyle/>
-          <a:p>
-            <a:r>
-              <a:rPr sz="1500" b="1">
-                <a:solidFill>
-                  <a:srgbClr val="6D28D9"/>
-                </a:solidFill>
-              </a:rPr>
-              <a:t>Live trace: mid-booking correction (scenario T04, virtual clock, real CPU time charged)</a:t>
-            </a:r>
-          </a:p>
-        </p:txBody>
-      </p:sp>
-      <p:sp>
-        <p:nvSpPr>
-          <p:cNvPr id="121" name="Rounded Rectangle 120"/>
-          <p:cNvSpPr/>
-          <p:nvPr/>
-        </p:nvSpPr>
-        <p:spPr>
-          <a:xfrm>
-            <a:off x="548640" y="1645920"/>
-            <a:ext cx="11109960" cy="3246120"/>
-          </a:xfrm>
-          <a:prstGeom prst="roundRect">
-            <a:avLst>
-              <a:gd name="adj" fmla="val 4000"/>
-            </a:avLst>
-          </a:prstGeom>
-          <a:solidFill>
-            <a:srgbClr val="0F172A"/>
-          </a:solidFill>
-          <a:ln>
-            <a:noFill/>
-          </a:ln>
-        </p:spPr>
-        <p:style>
-          <a:lnRef idx="1">
-            <a:schemeClr val="accent1"/>
-          </a:lnRef>
-          <a:fillRef idx="3">
-            <a:schemeClr val="accent1"/>
-          </a:fillRef>
-          <a:effectRef idx="2">
-            <a:schemeClr val="accent1"/>
-          </a:effectRef>
-          <a:fontRef idx="minor">
-            <a:schemeClr val="lt1"/>
-          </a:fontRef>
-        </p:style>
-        <p:txBody>
-          <a:bodyPr rtlCol="0" anchor="t" wrap="square" lIns="128016" tIns="128016"/>
-          <a:lstStyle/>
-          <a:p>
-            <a:pPr algn="l"/>
-            <a:r>
-              <a:rPr sz="1000">
-                <a:solidFill>
-                  <a:srgbClr val="FDE68A"/>
-                </a:solidFill>
-                <a:latin typeface="Consolas"/>
-              </a:rPr>
-              <a:t> 0.5000s  USER   says: "Book the cheapest flight from Pune to Chennai tomorrow for 2 passengers"</a:t>
-            </a:r>
-          </a:p>
-          <a:p>
-            <a:pPr algn="l"/>
-            <a:r>
-              <a:rPr sz="1000">
-                <a:solidFill>
-                  <a:srgbClr val="86EFAC"/>
-                </a:solidFill>
-                <a:latin typeface="Consolas"/>
-              </a:rPr>
-              <a:t> 0.5009s  AGENT  speak[ack] "Sure. Booking flight for 2."</a:t>
-            </a:r>
-          </a:p>
-          <a:p>
-            <a:pPr algn="l"/>
-            <a:r>
-              <a:rPr sz="1000">
-                <a:solidFill>
-                  <a:srgbClr val="93C5FD"/>
-                </a:solidFill>
-                <a:latin typeface="Consolas"/>
-              </a:rPr>
-              <a:t> 0.5009s  AGENT  tool_call call_001 search_flights({"origin": "Pune", "destination": "Chennai", "date": "2026-10-02", "passengers": 2})</a:t>
-            </a:r>
-          </a:p>
-          <a:p>
-            <a:pPr algn="l"/>
-            <a:r>
-              <a:rPr sz="1000">
-                <a:solidFill>
-                  <a:srgbClr val="94A3B8"/>
-                </a:solidFill>
-                <a:latin typeface="Consolas"/>
-              </a:rPr>
-              <a:t> 2.1009s  TOOL   result call_001 status=ok</a:t>
-            </a:r>
-          </a:p>
-          <a:p>
-            <a:pPr algn="l"/>
-            <a:r>
-              <a:rPr sz="1000">
-                <a:solidFill>
-                  <a:srgbClr val="93C5FD"/>
-                </a:solidFill>
-                <a:latin typeface="Consolas"/>
-              </a:rPr>
-              <a:t> 2.1010s  AGENT  tool_call call_002 book_flight({"flight_id": "UK-406", "passengers": 2})</a:t>
-            </a:r>
-          </a:p>
-          <a:p>
-            <a:pPr algn="l"/>
-            <a:r>
-              <a:rPr sz="1000">
-                <a:solidFill>
-                  <a:srgbClr val="FDE68A"/>
-                </a:solidFill>
-                <a:latin typeface="Consolas"/>
-              </a:rPr>
-              <a:t> 2.5000s  USER   barge-in (interruption signal)</a:t>
-            </a:r>
-          </a:p>
-          <a:p>
-            <a:pPr algn="l"/>
-            <a:r>
-              <a:rPr sz="1000">
-                <a:solidFill>
-                  <a:srgbClr val="FDE68A"/>
-                </a:solidFill>
-                <a:latin typeface="Consolas"/>
-              </a:rPr>
-              <a:t> 2.6000s  USER   says: "wait, make it 3 passengers"</a:t>
-            </a:r>
-          </a:p>
-          <a:p>
-            <a:pPr algn="l"/>
-            <a:r>
-              <a:rPr sz="1000">
-                <a:solidFill>
-                  <a:srgbClr val="FCA5A5"/>
-                </a:solidFill>
-                <a:latin typeface="Consolas"/>
-              </a:rPr>
-              <a:t> 2.6007s  AGENT  CANCEL call_002 (superseded_by_user_correction)</a:t>
-            </a:r>
-          </a:p>
-          <a:p>
-            <a:pPr algn="l"/>
-            <a:r>
-              <a:rPr sz="1000">
-                <a:solidFill>
-                  <a:srgbClr val="86EFAC"/>
-                </a:solidFill>
-                <a:latin typeface="Consolas"/>
-              </a:rPr>
-              <a:t> 2.6009s  AGENT  speak[ack] "Got it, updating that. Booking flight for 3."</a:t>
-            </a:r>
-          </a:p>
-          <a:p>
-            <a:pPr algn="l"/>
-            <a:r>
-              <a:rPr sz="1000">
-                <a:solidFill>
-                  <a:srgbClr val="93C5FD"/>
-                </a:solidFill>
-                <a:latin typeface="Consolas"/>
-              </a:rPr>
-              <a:t> 2.6009s  AGENT  tool_call call_003 book_flight({"flight_id": "UK-406", "passengers": 3})</a:t>
-            </a:r>
-          </a:p>
-          <a:p>
-            <a:pPr algn="l"/>
-            <a:r>
-              <a:rPr sz="1000">
-                <a:solidFill>
-                  <a:srgbClr val="94A3B8"/>
-                </a:solidFill>
-                <a:latin typeface="Consolas"/>
-              </a:rPr>
-              <a:t> 4.4009s  TOOL   result call_003 status=ok</a:t>
-            </a:r>
-          </a:p>
-          <a:p>
-            <a:pPr algn="l"/>
-            <a:r>
-              <a:rPr sz="1000">
-                <a:solidFill>
-                  <a:srgbClr val="C4B5FD"/>
-                </a:solidFill>
-                <a:latin typeface="Consolas"/>
-              </a:rPr>
-              <a:t> 4.4009s  AGENT  final_response "Done. Your flight is confirmed: BK959575 (confirmed, 3)."  slots={'passengers': 3, 'origin': 'Pune', 'destination': 'Chennai', 'date': '2026-10-02', 'flight_id': 'UK-406'}</a:t>
-            </a:r>
-          </a:p>
-          <a:p>
-            <a:pPr algn="l"/>
-            <a:r>
-              <a:rPr sz="1000">
-                <a:solidFill>
-                  <a:srgbClr val="FFFFFF"/>
-                </a:solidFill>
-                <a:latin typeface="Consolas"/>
-              </a:rPr>
-              <a:t/>
-            </a:r>
-          </a:p>
-          <a:p>
-            <a:pPr algn="l"/>
-            <a:r>
-              <a:rPr sz="1000">
-                <a:solidFill>
-                  <a:srgbClr val="FFFFFF"/>
-                </a:solidFill>
-                <a:latin typeface="Consolas"/>
-              </a:rPr>
-              <a:t>commits: 1 → book_flight({"flight_id": "UK-406", "passengers": 3})</a:t>
-            </a:r>
-          </a:p>
-        </p:txBody>
-      </p:sp>
-      <p:sp>
-        <p:nvSpPr>
-          <p:cNvPr id="122" name="Rounded Rectangle 121"/>
-          <p:cNvSpPr/>
-          <p:nvPr/>
-        </p:nvSpPr>
-        <p:spPr>
-          <a:xfrm>
-            <a:off x="548640" y="5029200"/>
-            <a:ext cx="5440680" cy="1508760"/>
-          </a:xfrm>
-          <a:prstGeom prst="roundRect">
-            <a:avLst>
-              <a:gd name="adj" fmla="val 6000"/>
-            </a:avLst>
-          </a:prstGeom>
-          <a:solidFill>
-            <a:srgbClr val="F8F9FB"/>
-          </a:solidFill>
-          <a:ln w="19050">
-            <a:solidFill>
-              <a:srgbClr val="059669"/>
-            </a:solidFill>
-          </a:ln>
-          <a:effectLst/>
-        </p:spPr>
-        <p:style>
-          <a:lnRef idx="1">
-            <a:schemeClr val="accent1"/>
-          </a:lnRef>
-          <a:fillRef idx="3">
-            <a:schemeClr val="accent1"/>
-          </a:fillRef>
-          <a:effectRef idx="2">
-            <a:schemeClr val="accent1"/>
-          </a:effectRef>
-          <a:fontRef idx="minor">
-            <a:schemeClr val="lt1"/>
-          </a:fontRef>
-        </p:style>
-        <p:txBody>
-          <a:bodyPr rtlCol="0" anchor="t" wrap="square" lIns="146304" rIns="146304" tIns="109728"/>
-          <a:lstStyle/>
-          <a:p>
-            <a:pPr algn="ctr"/>
-            <a:r>
-              <a:rPr sz="1450" b="1">
-                <a:solidFill>
-                  <a:srgbClr val="059669"/>
-                </a:solidFill>
-              </a:rPr>
-              <a:t>WHAT TO NOTICE</a:t>
-            </a:r>
-          </a:p>
-          <a:p>
-            <a:pPr>
-              <a:spcBef>
-                <a:spcPts val="300"/>
-              </a:spcBef>
-            </a:pPr>
-            <a:r>
-              <a:rPr sz="1050" b="1">
-                <a:solidFill>
-                  <a:srgbClr val="111827"/>
-                </a:solidFill>
-              </a:rPr>
-              <a:t>• The correction lands while book_flight(2) is in flight: </a:t>
-            </a:r>
-            <a:r>
-              <a:rPr sz="1050">
-                <a:solidFill>
-                  <a:srgbClr val="475569"/>
-                </a:solidFill>
-              </a:rPr>
-              <a:t>it is cancelled 0.8 ms later and re-issued with 3 passengers — exactly one commit.</a:t>
-            </a:r>
-          </a:p>
-          <a:p>
-            <a:pPr>
-              <a:spcBef>
-                <a:spcPts val="300"/>
-              </a:spcBef>
-            </a:pPr>
-            <a:r>
-              <a:rPr sz="1050" b="1">
-                <a:solidFill>
-                  <a:srgbClr val="111827"/>
-                </a:solidFill>
-              </a:rPr>
-              <a:t>• </a:t>
-            </a:r>
-            <a:r>
-              <a:rPr sz="1050">
-                <a:solidFill>
-                  <a:srgbClr val="475569"/>
-                </a:solidFill>
-              </a:rPr>
-              <a:t>Across the suite the first acknowledgment follows a user turn by 0.7 ms (median, max 5.3 ms); 'confirmed' is only said after the tool result.</a:t>
-            </a:r>
-          </a:p>
-        </p:txBody>
-      </p:sp>
-      <p:sp>
-        <p:nvSpPr>
-          <p:cNvPr id="123" name="Rounded Rectangle 122"/>
-          <p:cNvSpPr/>
-          <p:nvPr/>
-        </p:nvSpPr>
-        <p:spPr>
-          <a:xfrm>
-            <a:off x="6217920" y="5029200"/>
-            <a:ext cx="5440680" cy="1508760"/>
-          </a:xfrm>
-          <a:prstGeom prst="roundRect">
-            <a:avLst>
-              <a:gd name="adj" fmla="val 6000"/>
-            </a:avLst>
-          </a:prstGeom>
-          <a:solidFill>
-            <a:srgbClr val="F8F9FB"/>
-          </a:solidFill>
-          <a:ln w="19050">
-            <a:solidFill>
-              <a:srgbClr val="2563EB"/>
-            </a:solidFill>
-          </a:ln>
-          <a:effectLst/>
-        </p:spPr>
-        <p:style>
-          <a:lnRef idx="1">
-            <a:schemeClr val="accent1"/>
-          </a:lnRef>
-          <a:fillRef idx="3">
-            <a:schemeClr val="accent1"/>
-          </a:fillRef>
-          <a:effectRef idx="2">
-            <a:schemeClr val="accent1"/>
-          </a:effectRef>
-          <a:fontRef idx="minor">
-            <a:schemeClr val="lt1"/>
-          </a:fontRef>
-        </p:style>
-        <p:txBody>
-          <a:bodyPr rtlCol="0" anchor="t" wrap="square" lIns="146304" rIns="146304" tIns="109728"/>
-          <a:lstStyle/>
-          <a:p>
-            <a:pPr algn="ctr"/>
-            <a:r>
-              <a:rPr sz="1450" b="1">
-                <a:solidFill>
-                  <a:srgbClr val="2563EB"/>
-                </a:solidFill>
-              </a:rPr>
-              <a:t>REPRODUCE &amp; VIDEO</a:t>
-            </a:r>
-          </a:p>
-          <a:p>
-            <a:pPr>
-              <a:spcBef>
-                <a:spcPts val="300"/>
-              </a:spcBef>
-            </a:pPr>
-            <a:r>
-              <a:rPr sz="1050" b="1">
-                <a:solidFill>
-                  <a:srgbClr val="111827"/>
-                </a:solidFill>
-              </a:rPr>
-              <a:t>• </a:t>
-            </a:r>
-            <a:r>
-              <a:rPr sz="1050">
-                <a:solidFill>
-                  <a:srgbClr val="475569"/>
-                </a:solidFill>
-              </a:rPr>
-              <a:t>python run_eval.py --agent audient --show T04   (any scenario id works, e.g. V03 for camera + self-repair).</a:t>
-            </a:r>
-          </a:p>
-          <a:p>
-            <a:pPr>
-              <a:spcBef>
-                <a:spcPts val="300"/>
-              </a:spcBef>
-            </a:pPr>
-            <a:r>
-              <a:rPr sz="1050" b="1">
-                <a:solidFill>
-                  <a:srgbClr val="111827"/>
-                </a:solidFill>
-              </a:rPr>
-              <a:t>• Demo video (≤ 5 min): </a:t>
-            </a:r>
-            <a:r>
-              <a:rPr sz="1050">
-                <a:solidFill>
-                  <a:srgbClr val="475569"/>
-                </a:solidFill>
-              </a:rPr>
-              <a:t>[link to be added after recording].</a:t>
-            </a:r>
-          </a:p>
-        </p:txBody>
-      </p:sp>
-    </p:spTree>
-  </p:cSld>
-  <p:clrMapOvr>
-    <a:masterClrMapping/>
-  </p:clrMapOvr>
-</p:sld>
-</file>
-
-<file path=ppt/slides/slide6.xml><?xml version="1.0" encoding="utf-8"?>
-<p:sld xmlns:a="http://schemas.openxmlformats.org/drawingml/2006/main" xmlns:r="http://schemas.openxmlformats.org/officeDocument/2006/relationships" xmlns:mc="http://schemas.openxmlformats.org/markup-compatibility/2006" xmlns:mv="urn:schemas-microsoft-com:mac:vml" xmlns:p="http://schemas.openxmlformats.org/presentationml/2006/main" xmlns:c="http://schemas.openxmlformats.org/drawingml/2006/chart" xmlns:dgm="http://schemas.openxmlformats.org/drawingml/2006/diagram" xmlns:o="urn:schemas-microsoft-com:office:office" xmlns:v="urn:schemas-microsoft-com:vml" xmlns:pvml="urn:schemas-microsoft-com:office:powerpoint" xmlns:com="http://schemas.openxmlformats.org/drawingml/2006/compatibility" xmlns:p14="http://schemas.microsoft.com/office/powerpoint/2010/main" xmlns:p15="http://schemas.microsoft.com/office/powerpoint/2012/main" xmlns:ahyp="http://schemas.microsoft.com/office/drawing/2018/hyperlinkcolor">
-  <p:cSld>
-    <p:spTree>
-      <p:nvGrpSpPr>
-        <p:cNvPr id="124" name="Shape 124"/>
-        <p:cNvGrpSpPr/>
-        <p:nvPr/>
-      </p:nvGrpSpPr>
-      <p:grpSpPr>
-        <a:xfrm>
-          <a:off x="0" y="0"/>
-          <a:ext cx="0" cy="0"/>
-          <a:chOff x="0" y="0"/>
-          <a:chExt cx="0" cy="0"/>
-        </a:xfrm>
-      </p:grpSpPr>
-      <p:sp>
-        <p:nvSpPr>
-          <p:cNvPr id="125" name="Google Shape;125;p6"/>
-          <p:cNvSpPr txBox="1"/>
-          <p:nvPr>
-            <p:ph type="title"/>
-          </p:nvPr>
-        </p:nvSpPr>
-        <p:spPr>
-          <a:xfrm>
-            <a:off x="548640" y="201168"/>
-            <a:ext cx="11064240" cy="868680"/>
-          </a:xfrm>
-          <a:prstGeom prst="rect">
-            <a:avLst/>
-          </a:prstGeom>
-          <a:noFill/>
-          <a:ln>
-            <a:noFill/>
-          </a:ln>
-        </p:spPr>
-        <p:txBody>
-          <a:bodyPr anchorCtr="0" anchor="ctr" bIns="45700" lIns="91425" spcFirstLastPara="1" rIns="91425" wrap="square" tIns="45700">
-            <a:normAutofit/>
-          </a:bodyPr>
-          <a:lstStyle/>
-          <a:p>
-            <a:pPr indent="0" lvl="0" marL="0" rtl="0" algn="l">
-              <a:lnSpc>
-                <a:spcPct val="90000"/>
-              </a:lnSpc>
-              <a:spcBef>
-                <a:spcPts val="0"/>
-              </a:spcBef>
-              <a:spcAft>
-                <a:spcPts val="0"/>
-              </a:spcAft>
-              <a:buClr>
-                <a:srgbClr val="704EA6"/>
-              </a:buClr>
-              <a:buSzPts val="4400"/>
-              <a:buFont typeface="Calibri"/>
-              <a:buNone/>
-            </a:pPr>
-            <a:r>
-              <a:rPr b="1" lang="en-US" sz="3800">
-                <a:solidFill>
-                  <a:srgbClr val="704EA6"/>
-                </a:solidFill>
-                <a:latin typeface="Calibri"/>
-                <a:ea typeface="Calibri"/>
-                <a:cs typeface="Calibri"/>
-                <a:sym typeface="Calibri"/>
-              </a:rPr>
-              <a:t>Tools and tech stack used</a:t>
-            </a:r>
-            <a:endParaRPr b="1">
-              <a:solidFill>
-                <a:srgbClr val="704EA6"/>
-              </a:solidFill>
-            </a:endParaRPr>
-          </a:p>
-        </p:txBody>
-      </p:sp>
-      <p:sp>
-        <p:nvSpPr>
-          <p:cNvPr id="126" name="TextBox 125"/>
-          <p:cNvSpPr txBox="1"/>
-          <p:nvPr/>
-        </p:nvSpPr>
-        <p:spPr>
-          <a:xfrm>
-            <a:off x="566928" y="1051560"/>
-            <a:ext cx="11064240" cy="411480"/>
-          </a:xfrm>
-          <a:prstGeom prst="rect">
-            <a:avLst/>
-          </a:prstGeom>
-          <a:noFill/>
-        </p:spPr>
-        <p:txBody>
-          <a:bodyPr wrap="square">
-            <a:spAutoFit/>
-          </a:bodyPr>
-          <a:lstStyle/>
-          <a:p>
-            <a:r>
-              <a:rPr sz="1500" b="1">
-                <a:solidFill>
-                  <a:srgbClr val="6D28D9"/>
-                </a:solidFill>
-              </a:rPr>
-              <a:t>What the prototype actually runs on — offline, CPU-only, no API keys</a:t>
-            </a:r>
-          </a:p>
-        </p:txBody>
-      </p:sp>
-      <p:sp>
-        <p:nvSpPr>
-          <p:cNvPr id="127" name="Rounded Rectangle 126"/>
-          <p:cNvSpPr/>
-          <p:nvPr/>
-        </p:nvSpPr>
-        <p:spPr>
-          <a:xfrm>
-            <a:off x="548640" y="1645920"/>
-            <a:ext cx="5440680" cy="2377440"/>
-          </a:xfrm>
-          <a:prstGeom prst="roundRect">
-            <a:avLst>
-              <a:gd name="adj" fmla="val 6000"/>
-            </a:avLst>
-          </a:prstGeom>
-          <a:solidFill>
-            <a:srgbClr val="F8F9FB"/>
-          </a:solidFill>
-          <a:ln w="19050">
-            <a:solidFill>
-              <a:srgbClr val="059669"/>
-            </a:solidFill>
-          </a:ln>
-          <a:effectLst/>
-        </p:spPr>
-        <p:style>
-          <a:lnRef idx="1">
-            <a:schemeClr val="accent1"/>
-          </a:lnRef>
-          <a:fillRef idx="3">
-            <a:schemeClr val="accent1"/>
-          </a:fillRef>
-          <a:effectRef idx="2">
-            <a:schemeClr val="accent1"/>
-          </a:effectRef>
-          <a:fontRef idx="minor">
-            <a:schemeClr val="lt1"/>
-          </a:fontRef>
-        </p:style>
-        <p:txBody>
-          <a:bodyPr rtlCol="0" anchor="t" wrap="square" lIns="146304" rIns="146304" tIns="109728"/>
-          <a:lstStyle/>
-          <a:p>
-            <a:pPr algn="ctr"/>
-            <a:r>
-              <a:rPr sz="1650" b="1">
-                <a:solidFill>
-                  <a:srgbClr val="059669"/>
-                </a:solidFill>
-              </a:rPr>
-              <a:t>RUNTIME &amp; ORCHESTRATION</a:t>
-            </a:r>
-          </a:p>
-          <a:p>
-            <a:pPr>
-              <a:spcBef>
-                <a:spcPts val="300"/>
-              </a:spcBef>
-            </a:pPr>
-            <a:r>
-              <a:rPr sz="1250" b="1">
-                <a:solidFill>
-                  <a:srgbClr val="111827"/>
-                </a:solidFill>
-              </a:rPr>
-              <a:t>• Python asyncio: </a:t>
-            </a:r>
-            <a:r>
-              <a:rPr sz="1250">
-                <a:solidFill>
-                  <a:srgbClr val="475569"/>
-                </a:solidFill>
-              </a:rPr>
-              <a:t>fast path, slow-path tasks and the coordination layer in one event loop.</a:t>
-            </a:r>
-          </a:p>
-          <a:p>
-            <a:pPr>
-              <a:spcBef>
-                <a:spcPts val="300"/>
-              </a:spcBef>
-            </a:pPr>
-            <a:r>
-              <a:rPr sz="1250" b="1">
-                <a:solidFill>
-                  <a:srgbClr val="111827"/>
-                </a:solidFill>
-              </a:rPr>
-              <a:t>• Custom virtual-time event loop: </a:t>
-            </a:r>
-            <a:r>
-              <a:rPr sz="1250">
-                <a:solidFill>
-                  <a:srgbClr val="475569"/>
-                </a:solidFill>
-              </a:rPr>
-              <a:t>skips idle waits, charges real CPU time → honest latencies, fast replays.</a:t>
-            </a:r>
-          </a:p>
-          <a:p>
-            <a:pPr>
-              <a:spcBef>
-                <a:spcPts val="300"/>
-              </a:spcBef>
-            </a:pPr>
-            <a:r>
-              <a:rPr sz="1250" b="1">
-                <a:solidFill>
-                  <a:srgbClr val="111827"/>
-                </a:solidFill>
-              </a:rPr>
-              <a:t>• </a:t>
-            </a:r>
-            <a:r>
-              <a:rPr sz="1250">
-                <a:solidFill>
-                  <a:srgbClr val="475569"/>
-                </a:solidFill>
-              </a:rPr>
-              <a:t>Pure-Python cancellation DAG, commit ledger, SHA-256 idempotency (hashlib).</a:t>
-            </a:r>
-          </a:p>
-        </p:txBody>
-      </p:sp>
-      <p:sp>
-        <p:nvSpPr>
-          <p:cNvPr id="128" name="Rounded Rectangle 127"/>
-          <p:cNvSpPr/>
-          <p:nvPr/>
-        </p:nvSpPr>
-        <p:spPr>
-          <a:xfrm>
-            <a:off x="6217920" y="1645920"/>
-            <a:ext cx="5440680" cy="2377440"/>
-          </a:xfrm>
-          <a:prstGeom prst="roundRect">
-            <a:avLst>
-              <a:gd name="adj" fmla="val 6000"/>
-            </a:avLst>
-          </a:prstGeom>
-          <a:solidFill>
-            <a:srgbClr val="F8F9FB"/>
-          </a:solidFill>
-          <a:ln w="19050">
-            <a:solidFill>
-              <a:srgbClr val="2563EB"/>
-            </a:solidFill>
-          </a:ln>
-          <a:effectLst/>
-        </p:spPr>
-        <p:style>
-          <a:lnRef idx="1">
-            <a:schemeClr val="accent1"/>
-          </a:lnRef>
-          <a:fillRef idx="3">
-            <a:schemeClr val="accent1"/>
-          </a:fillRef>
-          <a:effectRef idx="2">
-            <a:schemeClr val="accent1"/>
-          </a:effectRef>
-          <a:fontRef idx="minor">
-            <a:schemeClr val="lt1"/>
-          </a:fontRef>
-        </p:style>
-        <p:txBody>
-          <a:bodyPr rtlCol="0" anchor="t" wrap="square" lIns="146304" rIns="146304" tIns="109728"/>
-          <a:lstStyle/>
-          <a:p>
-            <a:pPr algn="ctr"/>
-            <a:r>
-              <a:rPr sz="1650" b="1">
-                <a:solidFill>
-                  <a:srgbClr val="2563EB"/>
-                </a:solidFill>
-              </a:rPr>
-              <a:t>PERCEPTION</a:t>
-            </a:r>
-          </a:p>
-          <a:p>
-            <a:pPr>
-              <a:spcBef>
-                <a:spcPts val="300"/>
-              </a:spcBef>
-            </a:pPr>
-            <a:r>
-              <a:rPr sz="1250" b="1">
-                <a:solidFill>
-                  <a:srgbClr val="111827"/>
-                </a:solidFill>
-              </a:rPr>
-              <a:t>• RapidOCR (ONNX Runtime) + OpenCV: </a:t>
-            </a:r>
-            <a:r>
-              <a:rPr sz="1250">
-                <a:solidFill>
-                  <a:srgbClr val="475569"/>
-                </a:solidFill>
-              </a:rPr>
-              <a:t>error codes and model numbers from camera frames; LED colour from bright, round, saturated blobs; darkness/blur checks.</a:t>
-            </a:r>
-          </a:p>
-          <a:p>
-            <a:pPr>
-              <a:spcBef>
-                <a:spcPts val="300"/>
-              </a:spcBef>
-            </a:pPr>
-            <a:r>
-              <a:rPr sz="1250" b="1">
-                <a:solidFill>
-                  <a:srgbClr val="111827"/>
-                </a:solidFill>
-              </a:rPr>
-              <a:t>• </a:t>
-            </a:r>
-            <a:r>
-              <a:rPr sz="1250">
-                <a:solidFill>
-                  <a:srgbClr val="475569"/>
-                </a:solidFill>
-              </a:rPr>
-              <a:t>Whisper base.en via Hugging Face Transformers for WAV clips — implemented, optional, not benchmarked (model not downloaded).</a:t>
-            </a:r>
-          </a:p>
-        </p:txBody>
-      </p:sp>
-      <p:sp>
-        <p:nvSpPr>
-          <p:cNvPr id="129" name="Rounded Rectangle 128"/>
-          <p:cNvSpPr/>
-          <p:nvPr/>
-        </p:nvSpPr>
-        <p:spPr>
-          <a:xfrm>
-            <a:off x="548640" y="4160520"/>
-            <a:ext cx="5440680" cy="2377440"/>
-          </a:xfrm>
-          <a:prstGeom prst="roundRect">
-            <a:avLst>
-              <a:gd name="adj" fmla="val 6000"/>
-            </a:avLst>
-          </a:prstGeom>
-          <a:solidFill>
-            <a:srgbClr val="F8F9FB"/>
-          </a:solidFill>
-          <a:ln w="19050">
-            <a:solidFill>
-              <a:srgbClr val="6D28D9"/>
-            </a:solidFill>
-          </a:ln>
-          <a:effectLst/>
-        </p:spPr>
-        <p:style>
-          <a:lnRef idx="1">
-            <a:schemeClr val="accent1"/>
-          </a:lnRef>
-          <a:fillRef idx="3">
-            <a:schemeClr val="accent1"/>
-          </a:fillRef>
-          <a:effectRef idx="2">
-            <a:schemeClr val="accent1"/>
-          </a:effectRef>
-          <a:fontRef idx="minor">
-            <a:schemeClr val="lt1"/>
-          </a:fontRef>
-        </p:style>
-        <p:txBody>
-          <a:bodyPr rtlCol="0" anchor="t" wrap="square" lIns="146304" rIns="146304" tIns="109728"/>
-          <a:lstStyle/>
-          <a:p>
-            <a:pPr algn="ctr"/>
-            <a:r>
-              <a:rPr sz="1650" b="1">
-                <a:solidFill>
-                  <a:srgbClr val="6D28D9"/>
-                </a:solidFill>
-              </a:rPr>
-              <a:t>LANGUAGE UNDERSTANDING</a:t>
-            </a:r>
-          </a:p>
-          <a:p>
-            <a:pPr>
-              <a:spcBef>
-                <a:spcPts val="300"/>
-              </a:spcBef>
-            </a:pPr>
-            <a:r>
-              <a:rPr sz="1250" b="1">
-                <a:solidFill>
-                  <a:srgbClr val="111827"/>
-                </a:solidFill>
-              </a:rPr>
-              <a:t>• Deterministic, schema-driven NLU: </a:t>
-            </a:r>
-            <a:r>
-              <a:rPr sz="1250">
-                <a:solidFill>
-                  <a:srgbClr val="475569"/>
-                </a:solidFill>
-              </a:rPr>
-              <a:t>parameters are typed from the tool manifest (name, JSON type, enum, format), so unseen tools work without code changes.</a:t>
-            </a:r>
-          </a:p>
-          <a:p>
-            <a:pPr>
-              <a:spcBef>
-                <a:spcPts val="300"/>
-              </a:spcBef>
-            </a:pPr>
-            <a:r>
-              <a:rPr sz="1250" b="1">
-                <a:solidFill>
-                  <a:srgbClr val="111827"/>
-                </a:solidFill>
-              </a:rPr>
-              <a:t>• </a:t>
-            </a:r>
-            <a:r>
-              <a:rPr sz="1250">
-                <a:solidFill>
-                  <a:srgbClr val="475569"/>
-                </a:solidFill>
-              </a:rPr>
-              <a:t>Regex + lexicon extractors for places, dates, times, counts, codes, indicators, names; self-repair resolution.</a:t>
-            </a:r>
-          </a:p>
-        </p:txBody>
-      </p:sp>
-      <p:sp>
-        <p:nvSpPr>
-          <p:cNvPr id="130" name="Rounded Rectangle 129"/>
-          <p:cNvSpPr/>
-          <p:nvPr/>
-        </p:nvSpPr>
-        <p:spPr>
-          <a:xfrm>
-            <a:off x="6217920" y="4160520"/>
-            <a:ext cx="5440680" cy="2377440"/>
-          </a:xfrm>
-          <a:prstGeom prst="roundRect">
-            <a:avLst>
-              <a:gd name="adj" fmla="val 6000"/>
-            </a:avLst>
-          </a:prstGeom>
-          <a:solidFill>
-            <a:srgbClr val="F8F9FB"/>
-          </a:solidFill>
-          <a:ln w="19050">
-            <a:solidFill>
-              <a:srgbClr val="D97706"/>
-            </a:solidFill>
-          </a:ln>
-          <a:effectLst/>
-        </p:spPr>
-        <p:style>
-          <a:lnRef idx="1">
-            <a:schemeClr val="accent1"/>
-          </a:lnRef>
-          <a:fillRef idx="3">
-            <a:schemeClr val="accent1"/>
-          </a:fillRef>
-          <a:effectRef idx="2">
-            <a:schemeClr val="accent1"/>
-          </a:effectRef>
-          <a:fontRef idx="minor">
-            <a:schemeClr val="lt1"/>
-          </a:fontRef>
-        </p:style>
-        <p:txBody>
-          <a:bodyPr rtlCol="0" anchor="t" wrap="square" lIns="146304" rIns="146304" tIns="109728"/>
-          <a:lstStyle/>
-          <a:p>
-            <a:pPr algn="ctr"/>
-            <a:r>
-              <a:rPr sz="1650" b="1">
-                <a:solidFill>
-                  <a:srgbClr val="D97706"/>
-                </a:solidFill>
-              </a:rPr>
-              <a:t>EVALUATION &amp; PACKAGING</a:t>
-            </a:r>
-          </a:p>
-          <a:p>
-            <a:pPr>
-              <a:spcBef>
-                <a:spcPts val="300"/>
-              </a:spcBef>
-            </a:pPr>
-            <a:r>
-              <a:rPr sz="1250" b="1">
-                <a:solidFill>
-                  <a:srgbClr val="111827"/>
-                </a:solidFill>
-              </a:rPr>
-              <a:t>• </a:t>
-            </a:r>
-            <a:r>
-              <a:rPr sz="1250">
-                <a:solidFill>
-                  <a:srgbClr val="475569"/>
-                </a:solidFill>
-              </a:rPr>
-              <a:t>Streaming replay harness, deterministic mock tools (latency + fault injection), trace-based scorer (40/35/15/10, 15 ms grace).</a:t>
-            </a:r>
-          </a:p>
-          <a:p>
-            <a:pPr>
-              <a:spcBef>
-                <a:spcPts val="300"/>
-              </a:spcBef>
-            </a:pPr>
-            <a:r>
-              <a:rPr sz="1250" b="1">
-                <a:solidFill>
-                  <a:srgbClr val="111827"/>
-                </a:solidFill>
-              </a:rPr>
-              <a:t>• </a:t>
-            </a:r>
-            <a:r>
-              <a:rPr sz="1250">
-                <a:solidFill>
-                  <a:srgbClr val="475569"/>
-                </a:solidFill>
-              </a:rPr>
-              <a:t>pytest unit tests; run_evaluation.sh one-command run; Dockerfile + compose provided (not yet built — no Docker on the dev machine).</a:t>
+              <a:t>when Gemini cancels its own call and drops the reply, the agent asks it once to report the result.</a:t>
             </a:r>
           </a:p>
         </p:txBody>
@@ -17854,7 +15159,7 @@
                 <a:cs typeface="Calibri"/>
                 <a:sym typeface="Calibri"/>
               </a:rPr>
-              <a:t>Impact &amp; Use case</a:t>
+              <a:t>Extension use case</a:t>
             </a:r>
             <a:endParaRPr b="1">
               <a:solidFill>
@@ -17892,7 +15197,7 @@
                   <a:srgbClr val="6D28D9"/>
                 </a:solidFill>
               </a:rPr>
-              <a:t>Impact &amp; use cases — each one is a scenario in our test suite</a:t>
+              <a:t>Beyond the benchmark's domains: hands-free appliance troubleshooting from a camera frame</a:t>
             </a:r>
           </a:p>
         </p:txBody>
@@ -17906,6 +15211,146 @@
         <p:spPr>
           <a:xfrm>
             <a:off x="548640" y="1645920"/>
+            <a:ext cx="3611880" cy="4892040"/>
+          </a:xfrm>
+          <a:prstGeom prst="roundRect">
+            <a:avLst>
+              <a:gd name="adj" fmla="val 6000"/>
+            </a:avLst>
+          </a:prstGeom>
+          <a:solidFill>
+            <a:srgbClr val="F8F9FB"/>
+          </a:solidFill>
+          <a:ln w="19050">
+            <a:solidFill>
+              <a:srgbClr val="059669"/>
+            </a:solidFill>
+          </a:ln>
+          <a:effectLst/>
+        </p:spPr>
+        <p:style>
+          <a:lnRef idx="1">
+            <a:schemeClr val="accent1"/>
+          </a:lnRef>
+          <a:fillRef idx="3">
+            <a:schemeClr val="accent1"/>
+          </a:fillRef>
+          <a:effectRef idx="2">
+            <a:schemeClr val="accent1"/>
+          </a:effectRef>
+          <a:fontRef idx="minor">
+            <a:schemeClr val="lt1"/>
+          </a:fontRef>
+        </p:style>
+        <p:txBody>
+          <a:bodyPr rtlCol="0" anchor="t" wrap="square" lIns="146304" rIns="146304" tIns="109728"/>
+          <a:lstStyle/>
+          <a:p>
+            <a:pPr algn="ctr"/>
+            <a:r>
+              <a:rPr sz="1650" b="1">
+                <a:solidFill>
+                  <a:srgbClr val="059669"/>
+                </a:solidFill>
+              </a:rPr>
+              <a:t>THE USE CASE</a:t>
+            </a:r>
+          </a:p>
+          <a:p>
+            <a:pPr algn="ctr">
+              <a:spcAft>
+                <a:spcPts val="400"/>
+              </a:spcAft>
+            </a:pPr>
+            <a:r>
+              <a:rPr sz="1450" b="1">
+                <a:solidFill>
+                  <a:srgbClr val="111827"/>
+                </a:solidFill>
+              </a:rPr>
+              <a:t>Camera-grounded troubleshooting</a:t>
+            </a:r>
+          </a:p>
+          <a:p>
+            <a:pPr>
+              <a:spcBef>
+                <a:spcPts val="300"/>
+              </a:spcBef>
+            </a:pPr>
+            <a:r>
+              <a:rPr sz="1250" b="1">
+                <a:solidFill>
+                  <a:srgbClr val="111827"/>
+                </a:solidFill>
+              </a:rPr>
+              <a:t>• </a:t>
+            </a:r>
+            <a:r>
+              <a:rPr sz="1250">
+                <a:solidFill>
+                  <a:srgbClr val="475569"/>
+                </a:solidFill>
+              </a:rPr>
+              <a:t>'My washer shows error E-20…' → reads model WM-3000 from the frame, looks up E20.</a:t>
+            </a:r>
+          </a:p>
+          <a:p>
+            <a:pPr>
+              <a:spcBef>
+                <a:spcPts val="300"/>
+              </a:spcBef>
+            </a:pPr>
+            <a:r>
+              <a:rPr sz="1250" b="1">
+                <a:solidFill>
+                  <a:srgbClr val="111827"/>
+                </a:solidFill>
+              </a:rPr>
+              <a:t>• </a:t>
+            </a:r>
+            <a:r>
+              <a:rPr sz="1250">
+                <a:solidFill>
+                  <a:srgbClr val="475569"/>
+                </a:solidFill>
+              </a:rPr>
+              <a:t>'…wait, no, the red light stopped, now it's blinking blue twice' → drops the stale E20 request, grounds the new symptom, answers from the manual (valve fault).</a:t>
+            </a:r>
+          </a:p>
+          <a:p>
+            <a:pPr>
+              <a:spcBef>
+                <a:spcPts val="300"/>
+              </a:spcBef>
+            </a:pPr>
+            <a:r>
+              <a:rPr sz="1250" b="1">
+                <a:solidFill>
+                  <a:srgbClr val="111827"/>
+                </a:solidFill>
+              </a:rPr>
+              <a:t>• </a:t>
+            </a:r>
+            <a:r>
+              <a:rPr sz="1250">
+                <a:solidFill>
+                  <a:srgbClr val="475569"/>
+                </a:solidFill>
+              </a:rPr>
+              <a:t>Too-dark frame → asks the user to move closer instead of guessing.</a:t>
+            </a:r>
+          </a:p>
+        </p:txBody>
+      </p:sp>
+      <p:sp>
+        <p:nvSpPr>
+          <p:cNvPr id="134" name="Rounded Rectangle 133"/>
+          <p:cNvSpPr/>
+          <p:nvPr/>
+        </p:nvSpPr>
+        <p:spPr>
+          <a:xfrm>
+            <a:off x="4297680" y="1645920"/>
             <a:ext cx="3611880" cy="4892040"/>
           </a:xfrm>
           <a:prstGeom prst="roundRect">
@@ -17948,7 +15393,7 @@
                   <a:srgbClr val="2563EB"/>
                 </a:solidFill>
               </a:rPr>
-              <a:t>TOOL DOMAINS</a:t>
+              <a:t>RUNS END TO END</a:t>
             </a:r>
           </a:p>
           <a:p>
@@ -17963,7 +15408,7 @@
                   <a:srgbClr val="111827"/>
                 </a:solidFill>
               </a:rPr>
-              <a:t>What the agent can drive today</a:t>
+              <a:t>How to try it</a:t>
             </a:r>
           </a:p>
           <a:p>
@@ -17978,7 +15423,7 @@
                   <a:srgbClr val="111827"/>
                 </a:solidFill>
               </a:rPr>
-              <a:t>• Travel: </a:t>
+              <a:t>• Web app: </a:t>
             </a:r>
             <a:r>
               <a:rPr sz="1250">
@@ -17986,7 +15431,7 @@
                   <a:srgbClr val="475569"/>
                 </a:solidFill>
               </a:rPr>
-              <a:t>flight search → cheapest-flight booking (chained calls).</a:t>
+              <a:t>python api/run.py, open localhost:8000, pick or upload a camera frame, then speak or type.</a:t>
             </a:r>
           </a:p>
           <a:p>
@@ -18001,7 +15446,7 @@
                   <a:srgbClr val="111827"/>
                 </a:solidFill>
               </a:rPr>
-              <a:t>• In-car: </a:t>
+              <a:t>• Scripted run: </a:t>
             </a:r>
             <a:r>
               <a:rPr sz="1250">
@@ -18009,7 +15454,7 @@
                   <a:srgbClr val="475569"/>
                 </a:solidFill>
               </a:rPr>
-              <a:t>route to a destination that changes mid-calculation.</a:t>
+              <a:t>python run_eval.py --agent audient --show V03 prints every timestamped action.</a:t>
             </a:r>
           </a:p>
           <a:p>
@@ -18024,7 +15469,7 @@
                   <a:srgbClr val="111827"/>
                 </a:solidFill>
               </a:rPr>
-              <a:t>• Support: </a:t>
+              <a:t>• Perception: </a:t>
             </a:r>
             <a:r>
               <a:rPr sz="1250">
@@ -18032,7 +15477,7 @@
                   <a:srgbClr val="475569"/>
                 </a:solidFill>
               </a:rPr>
-              <a:t>tickets with priority from 'it's urgent'.</a:t>
+              <a:t>RapidOCR + OpenCV read the model, error code and LED colour on the CPU.</a:t>
             </a:r>
           </a:p>
           <a:p>
@@ -18047,7 +15492,7 @@
                   <a:srgbClr val="111827"/>
                 </a:solidFill>
               </a:rPr>
-              <a:t>• Unseen tool: </a:t>
+              <a:t>• Scope: </a:t>
             </a:r>
             <a:r>
               <a:rPr sz="1250">
@@ -18055,170 +15500,7 @@
                   <a:srgbClr val="475569"/>
                 </a:solidFill>
               </a:rPr>
-              <a:t>a restaurant reservation tool it never saw, driven purely from the manifest.</a:t>
-            </a:r>
-          </a:p>
-          <a:p>
-            <a:pPr>
-              <a:spcBef>
-                <a:spcPts val="300"/>
-              </a:spcBef>
-            </a:pPr>
-            <a:r>
-              <a:rPr sz="1250" b="1">
-                <a:solidFill>
-                  <a:srgbClr val="111827"/>
-                </a:solidFill>
-              </a:rPr>
-              <a:t>• </a:t>
-            </a:r>
-            <a:r>
-              <a:rPr sz="1250">
-                <a:solidFill>
-                  <a:srgbClr val="475569"/>
-                </a:solidFill>
-              </a:rPr>
-              <a:t>Zero double bookings across the whole suite, including a mid-booking passenger change.</a:t>
-            </a:r>
-          </a:p>
-        </p:txBody>
-      </p:sp>
-      <p:sp>
-        <p:nvSpPr>
-          <p:cNvPr id="134" name="Rounded Rectangle 133"/>
-          <p:cNvSpPr/>
-          <p:nvPr/>
-        </p:nvSpPr>
-        <p:spPr>
-          <a:xfrm>
-            <a:off x="4297680" y="1645920"/>
-            <a:ext cx="3611880" cy="4892040"/>
-          </a:xfrm>
-          <a:prstGeom prst="roundRect">
-            <a:avLst>
-              <a:gd name="adj" fmla="val 6000"/>
-            </a:avLst>
-          </a:prstGeom>
-          <a:solidFill>
-            <a:srgbClr val="F8F9FB"/>
-          </a:solidFill>
-          <a:ln w="19050">
-            <a:solidFill>
-              <a:srgbClr val="059669"/>
-            </a:solidFill>
-          </a:ln>
-          <a:effectLst/>
-        </p:spPr>
-        <p:style>
-          <a:lnRef idx="1">
-            <a:schemeClr val="accent1"/>
-          </a:lnRef>
-          <a:fillRef idx="3">
-            <a:schemeClr val="accent1"/>
-          </a:fillRef>
-          <a:effectRef idx="2">
-            <a:schemeClr val="accent1"/>
-          </a:effectRef>
-          <a:fontRef idx="minor">
-            <a:schemeClr val="lt1"/>
-          </a:fontRef>
-        </p:style>
-        <p:txBody>
-          <a:bodyPr rtlCol="0" anchor="t" wrap="square" lIns="146304" rIns="146304" tIns="109728"/>
-          <a:lstStyle/>
-          <a:p>
-            <a:pPr algn="ctr"/>
-            <a:r>
-              <a:rPr sz="1650" b="1">
-                <a:solidFill>
-                  <a:srgbClr val="059669"/>
-                </a:solidFill>
-              </a:rPr>
-              <a:t>MULTIMODAL</a:t>
-            </a:r>
-          </a:p>
-          <a:p>
-            <a:pPr algn="ctr">
-              <a:spcAft>
-                <a:spcPts val="400"/>
-              </a:spcAft>
-            </a:pPr>
-            <a:r>
-              <a:rPr sz="1450" b="1">
-                <a:solidFill>
-                  <a:srgbClr val="111827"/>
-                </a:solidFill>
-              </a:rPr>
-              <a:t>Camera-grounded troubleshooting</a:t>
-            </a:r>
-          </a:p>
-          <a:p>
-            <a:pPr>
-              <a:spcBef>
-                <a:spcPts val="300"/>
-              </a:spcBef>
-            </a:pPr>
-            <a:r>
-              <a:rPr sz="1250" b="1">
-                <a:solidFill>
-                  <a:srgbClr val="111827"/>
-                </a:solidFill>
-              </a:rPr>
-              <a:t>• </a:t>
-            </a:r>
-            <a:r>
-              <a:rPr sz="1250">
-                <a:solidFill>
-                  <a:srgbClr val="475569"/>
-                </a:solidFill>
-              </a:rPr>
-              <a:t>'My washer shows error E-20…' → reads model WM-3000 from the frame, looks up E20.</a:t>
-            </a:r>
-          </a:p>
-          <a:p>
-            <a:pPr>
-              <a:spcBef>
-                <a:spcPts val="300"/>
-              </a:spcBef>
-            </a:pPr>
-            <a:r>
-              <a:rPr sz="1250" b="1">
-                <a:solidFill>
-                  <a:srgbClr val="111827"/>
-                </a:solidFill>
-              </a:rPr>
-              <a:t>• </a:t>
-            </a:r>
-            <a:r>
-              <a:rPr sz="1250">
-                <a:solidFill>
-                  <a:srgbClr val="475569"/>
-                </a:solidFill>
-              </a:rPr>
-              <a:t>'…wait, no, the red light stopped, now it's blinking blue twice' → cancels the E20 lookup, grounds the new symptom, answers from the manual (valve fault).</a:t>
-            </a:r>
-          </a:p>
-          <a:p>
-            <a:pPr>
-              <a:spcBef>
-                <a:spcPts val="300"/>
-              </a:spcBef>
-            </a:pPr>
-            <a:r>
-              <a:rPr sz="1250" b="1">
-                <a:solidFill>
-                  <a:srgbClr val="111827"/>
-                </a:solidFill>
-              </a:rPr>
-              <a:t>• </a:t>
-            </a:r>
-            <a:r>
-              <a:rPr sz="1250">
-                <a:solidFill>
-                  <a:srgbClr val="475569"/>
-                </a:solidFill>
-              </a:rPr>
-              <a:t>Too-dark frame → asks the user to move closer instead of guessing.</a:t>
+              <a:t>runs on Audient's original event-driven agent (same correction rules), not yet inside the LiveKit agent.</a:t>
             </a:r>
           </a:p>
         </p:txBody>
@@ -18304,7 +15586,7 @@
                   <a:srgbClr val="111827"/>
                 </a:solidFill>
               </a:rPr>
-              <a:t>• Drivers: </a:t>
+              <a:t>• Field technicians: </a:t>
             </a:r>
             <a:r>
               <a:rPr sz="1250">
@@ -18312,7 +15594,30 @@
                   <a:srgbClr val="475569"/>
                 </a:solidFill>
               </a:rPr>
-              <a:t>change destinations hands-free without stale routes.</a:t>
+              <a:t>hands-free manual lookup grounded in what the camera sees.</a:t>
+            </a:r>
+          </a:p>
+          <a:p>
+            <a:pPr>
+              <a:spcBef>
+                <a:spcPts val="300"/>
+              </a:spcBef>
+            </a:pPr>
+            <a:r>
+              <a:rPr sz="1250" b="1">
+                <a:solidFill>
+                  <a:srgbClr val="111827"/>
+                </a:solidFill>
+              </a:rPr>
+              <a:t>• Home users: </a:t>
+            </a:r>
+            <a:r>
+              <a:rPr sz="1250">
+                <a:solidFill>
+                  <a:srgbClr val="475569"/>
+                </a:solidFill>
+              </a:rPr>
+              <a:t>describe a fault, change their mind, and get the answer for the fault they meant.</a:t>
             </a:r>
           </a:p>
           <a:p>
@@ -18336,52 +15641,6 @@
                 </a:solidFill>
               </a:rPr>
               <a:t>pauses, fillers and stutters don't cut them off.</a:t>
-            </a:r>
-          </a:p>
-          <a:p>
-            <a:pPr>
-              <a:spcBef>
-                <a:spcPts val="300"/>
-              </a:spcBef>
-            </a:pPr>
-            <a:r>
-              <a:rPr sz="1250" b="1">
-                <a:solidFill>
-                  <a:srgbClr val="111827"/>
-                </a:solidFill>
-              </a:rPr>
-              <a:t>• Contact centres: </a:t>
-            </a:r>
-            <a:r>
-              <a:rPr sz="1250">
-                <a:solidFill>
-                  <a:srgbClr val="475569"/>
-                </a:solidFill>
-              </a:rPr>
-              <a:t>no double transactions when customers change their minds mid-booking.</a:t>
-            </a:r>
-          </a:p>
-          <a:p>
-            <a:pPr>
-              <a:spcBef>
-                <a:spcPts val="300"/>
-              </a:spcBef>
-            </a:pPr>
-            <a:r>
-              <a:rPr sz="1250" b="1">
-                <a:solidFill>
-                  <a:srgbClr val="111827"/>
-                </a:solidFill>
-              </a:rPr>
-              <a:t>• Field technicians: </a:t>
-            </a:r>
-            <a:r>
-              <a:rPr sz="1250">
-                <a:solidFill>
-                  <a:srgbClr val="475569"/>
-                </a:solidFill>
-              </a:rPr>
-              <a:t>hands-free manual lookup grounded in what the camera sees.</a:t>
             </a:r>
           </a:p>
         </p:txBody>
@@ -18465,7 +15724,7 @@
                 <a:cs typeface="Calibri"/>
                 <a:sym typeface="Calibri"/>
               </a:rPr>
-              <a:t>Innovation highlights, results and limitations</a:t>
+              <a:t>Benchmark results</a:t>
             </a:r>
             <a:endParaRPr b="1" sz="4400">
               <a:solidFill>
@@ -18503,7 +15762,7 @@
                   <a:srgbClr val="6D28D9"/>
                 </a:solidFill>
               </a:rPr>
-              <a:t>Innovations, measured results (15 scenarios, our harness) and honest limitations</a:t>
+              <a:t>Full-Duplex-Bench v3: all 100 recordings on GitHub Codespaces, arguments compared exactly (no GPT-4o judge)</a:t>
             </a:r>
           </a:p>
         </p:txBody>
@@ -18559,7 +15818,7 @@
                   <a:srgbClr val="6D28D9"/>
                 </a:solidFill>
               </a:rPr>
-              <a:t>INNOVATIONS</a:t>
+              <a:t>WHAT WE COMPARED</a:t>
             </a:r>
           </a:p>
           <a:p>
@@ -18574,7 +15833,7 @@
                   <a:srgbClr val="111827"/>
                 </a:solidFill>
               </a:rPr>
-              <a:t>• </a:t>
+              <a:t>• Same model, voice and tools: </a:t>
             </a:r>
             <a:r>
               <a:rPr sz="1150">
@@ -18582,7 +15841,7 @@
                   <a:srgbClr val="475569"/>
                 </a:solidFill>
               </a:rPr>
-              <a:t>Cancellation graph over calls, retries and timers.</a:t>
+              <a:t>FDB-v3's own gemini2_5 agent is the baseline; Audient adds its layer and a few instructions.</a:t>
             </a:r>
           </a:p>
           <a:p>
@@ -18597,7 +15856,7 @@
                   <a:srgbClr val="111827"/>
                 </a:solidFill>
               </a:rPr>
-              <a:t>• Two-tier slots: </a:t>
+              <a:t>• Strict pass: </a:t>
             </a:r>
             <a:r>
               <a:rPr sz="1150">
@@ -18605,7 +15864,7 @@
                   <a:srgbClr val="475569"/>
                 </a:solidFill>
               </a:rPr>
-              <a:t>tentative (partial speech) vs committed.</a:t>
+              <a:t>every expected call, with the right arguments.</a:t>
             </a:r>
           </a:p>
           <a:p>
@@ -18620,7 +15879,7 @@
                   <a:srgbClr val="111827"/>
                 </a:solidFill>
               </a:rPr>
-              <a:t>• Idempotency barrier: </a:t>
+              <a:t>• Reproduce: </a:t>
             </a:r>
             <a:r>
               <a:rPr sz="1150">
@@ -18628,53 +15887,7 @@
                   <a:srgbClr val="475569"/>
                 </a:solidFill>
               </a:rPr>
-              <a:t>SHA-256 keys + commit ledger + late-commit reconciliation.</a:t>
-            </a:r>
-          </a:p>
-          <a:p>
-            <a:pPr>
-              <a:spcBef>
-                <a:spcPts val="300"/>
-              </a:spcBef>
-            </a:pPr>
-            <a:r>
-              <a:rPr sz="1150" b="1">
-                <a:solidFill>
-                  <a:srgbClr val="111827"/>
-                </a:solidFill>
-              </a:rPr>
-              <a:t>• </a:t>
-            </a:r>
-            <a:r>
-              <a:rPr sz="1150">
-                <a:solidFill>
-                  <a:srgbClr val="475569"/>
-                </a:solidFill>
-              </a:rPr>
-              <a:t>Semantic end-of-turn hold for pauses and fillers.</a:t>
-            </a:r>
-          </a:p>
-          <a:p>
-            <a:pPr>
-              <a:spcBef>
-                <a:spcPts val="300"/>
-              </a:spcBef>
-            </a:pPr>
-            <a:r>
-              <a:rPr sz="1150" b="1">
-                <a:solidFill>
-                  <a:srgbClr val="111827"/>
-                </a:solidFill>
-              </a:rPr>
-              <a:t>• </a:t>
-            </a:r>
-            <a:r>
-              <a:rPr sz="1150">
-                <a:solidFill>
-                  <a:srgbClr val="475569"/>
-                </a:solidFill>
-              </a:rPr>
-              <a:t>Virtual clock that charges real CPU — found and fixed a GIL-contention bug (cancel took 17.7 ms while OCR ran).</a:t>
+              <a:t>bash fdb_agent/setup.sh, then bash fdb_agent/run_benchmark.sh audient.</a:t>
             </a:r>
           </a:p>
         </p:txBody>
@@ -18689,7 +15902,7 @@
         </p:nvGraphicFramePr>
         <p:xfrm>
           <a:off x="3977639" y="1691640"/>
-          <a:ext cx="4206240" cy="4023360"/>
+          <a:ext cx="4206240" cy="3566160"/>
         </p:xfrm>
         <a:graphic>
           <a:graphicData uri="http://schemas.openxmlformats.org/drawingml/2006/table">
@@ -18702,7 +15915,7 @@
                 <a:gridCol w="1097280"/>
                 <a:gridCol w="1097280"/>
               </a:tblGrid>
-              <a:tr h="447040">
+              <a:tr h="509451">
                 <a:tc>
                   <a:txBody>
                     <a:bodyPr/>
@@ -18710,7 +15923,7 @@
                     <a:p>
                       <a:pPr algn="l"/>
                       <a:r>
-                        <a:rPr sz="1050" b="1">
+                        <a:rPr sz="1100" b="1">
                           <a:solidFill>
                             <a:srgbClr val="FFFFFF"/>
                           </a:solidFill>
@@ -18732,7 +15945,7 @@
                     <a:p>
                       <a:pPr algn="ctr"/>
                       <a:r>
-                        <a:rPr sz="1050" b="1">
+                        <a:rPr sz="1100" b="1">
                           <a:solidFill>
                             <a:srgbClr val="FFFFFF"/>
                           </a:solidFill>
@@ -18754,12 +15967,12 @@
                     <a:p>
                       <a:pPr algn="ctr"/>
                       <a:r>
-                        <a:rPr sz="1050" b="1">
+                        <a:rPr sz="1100" b="1">
                           <a:solidFill>
                             <a:srgbClr val="FFFFFF"/>
                           </a:solidFill>
                         </a:rPr>
-                        <a:t>Half-duplex</a:t>
+                        <a:t>FDB Gemini</a:t>
                       </a:r>
                     </a:p>
                   </a:txBody>
@@ -18770,7 +15983,7 @@
                   </a:tcPr>
                 </a:tc>
               </a:tr>
-              <a:tr h="447040">
+              <a:tr h="509451">
                 <a:tc>
                   <a:txBody>
                     <a:bodyPr/>
@@ -18778,12 +15991,12 @@
                     <a:p>
                       <a:pPr algn="l"/>
                       <a:r>
-                        <a:rPr sz="1050" b="0">
+                        <a:rPr sz="1100" b="0">
                           <a:solidFill>
                             <a:srgbClr val="111827"/>
                           </a:solidFill>
                         </a:rPr>
-                        <a:t>Scenarios, all checks pass</a:t>
+                        <a:t>Strict pass rate</a:t>
                       </a:r>
                     </a:p>
                   </a:txBody>
@@ -18800,12 +16013,12 @@
                     <a:p>
                       <a:pPr algn="ctr"/>
                       <a:r>
-                        <a:rPr sz="1050" b="1">
+                        <a:rPr sz="1100" b="1">
                           <a:solidFill>
-                            <a:srgbClr val="059669"/>
+                            <a:srgbClr val="111827"/>
                           </a:solidFill>
                         </a:rPr>
-                        <a:t>15/15</a:t>
+                        <a:t>47.0%</a:t>
                       </a:r>
                     </a:p>
                   </a:txBody>
@@ -18822,12 +16035,12 @@
                     <a:p>
                       <a:pPr algn="ctr"/>
                       <a:r>
-                        <a:rPr sz="1050" b="0">
+                        <a:rPr sz="1100" b="0">
                           <a:solidFill>
                             <a:srgbClr val="111827"/>
                           </a:solidFill>
                         </a:rPr>
-                        <a:t>1/15</a:t>
+                        <a:t>47.0%</a:t>
                       </a:r>
                     </a:p>
                   </a:txBody>
@@ -18838,7 +16051,7 @@
                   </a:tcPr>
                 </a:tc>
               </a:tr>
-              <a:tr h="447040">
+              <a:tr h="509451">
                 <a:tc>
                   <a:txBody>
                     <a:bodyPr/>
@@ -18846,12 +16059,12 @@
                     <a:p>
                       <a:pPr algn="l"/>
                       <a:r>
-                        <a:rPr sz="1050" b="0">
+                        <a:rPr sz="1100" b="0">
                           <a:solidFill>
                             <a:srgbClr val="111827"/>
                           </a:solidFill>
                         </a:rPr>
-                        <a:t>Weighted score (pre-multiplier)</a:t>
+                        <a:t>Self-correction</a:t>
                       </a:r>
                     </a:p>
                   </a:txBody>
@@ -18868,12 +16081,12 @@
                     <a:p>
                       <a:pPr algn="ctr"/>
                       <a:r>
-                        <a:rPr sz="1050" b="1">
+                        <a:rPr sz="1100" b="1">
                           <a:solidFill>
-                            <a:srgbClr val="059669"/>
+                            <a:srgbClr val="111827"/>
                           </a:solidFill>
                         </a:rPr>
-                        <a:t>100.0</a:t>
+                        <a:t>70.6%</a:t>
                       </a:r>
                     </a:p>
                   </a:txBody>
@@ -18890,12 +16103,12 @@
                     <a:p>
                       <a:pPr algn="ctr"/>
                       <a:r>
-                        <a:rPr sz="1050" b="0">
+                        <a:rPr sz="1100" b="0">
                           <a:solidFill>
                             <a:srgbClr val="111827"/>
                           </a:solidFill>
                         </a:rPr>
-                        <a:t>75.3</a:t>
+                        <a:t>41.2%</a:t>
                       </a:r>
                     </a:p>
                   </a:txBody>
@@ -18906,7 +16119,7 @@
                   </a:tcPr>
                 </a:tc>
               </a:tr>
-              <a:tr h="447040">
+              <a:tr h="509451">
                 <a:tc>
                   <a:txBody>
                     <a:bodyPr/>
@@ -18914,12 +16127,12 @@
                     <a:p>
                       <a:pPr algn="l"/>
                       <a:r>
-                        <a:rPr sz="1050" b="0">
+                        <a:rPr sz="1100" b="0">
                           <a:solidFill>
                             <a:srgbClr val="111827"/>
                           </a:solidFill>
                         </a:rPr>
-                        <a:t>Task completion</a:t>
+                        <a:t>Medium (2 tools)</a:t>
                       </a:r>
                     </a:p>
                   </a:txBody>
@@ -18936,12 +16149,12 @@
                     <a:p>
                       <a:pPr algn="ctr"/>
                       <a:r>
-                        <a:rPr sz="1050" b="1">
+                        <a:rPr sz="1100" b="1">
                           <a:solidFill>
-                            <a:srgbClr val="059669"/>
+                            <a:srgbClr val="111827"/>
                           </a:solidFill>
                         </a:rPr>
-                        <a:t>100%</a:t>
+                        <a:t>52.9%</a:t>
                       </a:r>
                     </a:p>
                   </a:txBody>
@@ -18958,12 +16171,12 @@
                     <a:p>
                       <a:pPr algn="ctr"/>
                       <a:r>
-                        <a:rPr sz="1050" b="0">
+                        <a:rPr sz="1100" b="0">
                           <a:solidFill>
                             <a:srgbClr val="111827"/>
                           </a:solidFill>
                         </a:rPr>
-                        <a:t>88%</a:t>
+                        <a:t>44.1%</a:t>
                       </a:r>
                     </a:p>
                   </a:txBody>
@@ -18974,7 +16187,7 @@
                   </a:tcPr>
                 </a:tc>
               </a:tr>
-              <a:tr h="447040">
+              <a:tr h="509451">
                 <a:tc>
                   <a:txBody>
                     <a:bodyPr/>
@@ -18982,12 +16195,12 @@
                     <a:p>
                       <a:pPr algn="l"/>
                       <a:r>
-                        <a:rPr sz="1050" b="0">
+                        <a:rPr sz="1100" b="0">
                           <a:solidFill>
                             <a:srgbClr val="111827"/>
                           </a:solidFill>
                         </a:rPr>
-                        <a:t>Interruption recovery</a:t>
+                        <a:t>Hard (3-tool chains)</a:t>
                       </a:r>
                     </a:p>
                   </a:txBody>
@@ -19004,12 +16217,12 @@
                     <a:p>
                       <a:pPr algn="ctr"/>
                       <a:r>
-                        <a:rPr sz="1050" b="1">
+                        <a:rPr sz="1100" b="1">
                           <a:solidFill>
-                            <a:srgbClr val="059669"/>
+                            <a:srgbClr val="111827"/>
                           </a:solidFill>
                         </a:rPr>
-                        <a:t>100%</a:t>
+                        <a:t>36.7%</a:t>
                       </a:r>
                     </a:p>
                   </a:txBody>
@@ -19026,12 +16239,12 @@
                     <a:p>
                       <a:pPr algn="ctr"/>
                       <a:r>
-                        <a:rPr sz="1050" b="0">
+                        <a:rPr sz="1100" b="0">
                           <a:solidFill>
                             <a:srgbClr val="111827"/>
                           </a:solidFill>
                         </a:rPr>
-                        <a:t>69%</a:t>
+                        <a:t>40.0%</a:t>
                       </a:r>
                     </a:p>
                   </a:txBody>
@@ -19042,7 +16255,7 @@
                   </a:tcPr>
                 </a:tc>
               </a:tr>
-              <a:tr h="447040">
+              <a:tr h="509451">
                 <a:tc>
                   <a:txBody>
                     <a:bodyPr/>
@@ -19050,12 +16263,12 @@
                     <a:p>
                       <a:pPr algn="l"/>
                       <a:r>
-                        <a:rPr sz="1050" b="0">
+                        <a:rPr sz="1100" b="0">
                           <a:solidFill>
                             <a:srgbClr val="111827"/>
                           </a:solidFill>
                         </a:rPr>
-                        <a:t>Latency credit</a:t>
+                        <a:t>Replied at all</a:t>
                       </a:r>
                     </a:p>
                   </a:txBody>
@@ -19072,12 +16285,12 @@
                     <a:p>
                       <a:pPr algn="ctr"/>
                       <a:r>
-                        <a:rPr sz="1050" b="1">
+                        <a:rPr sz="1100" b="1">
                           <a:solidFill>
-                            <a:srgbClr val="059669"/>
+                            <a:srgbClr val="111827"/>
                           </a:solidFill>
                         </a:rPr>
-                        <a:t>100%</a:t>
+                        <a:t>82/100</a:t>
                       </a:r>
                     </a:p>
                   </a:txBody>
@@ -19094,12 +16307,12 @@
                     <a:p>
                       <a:pPr algn="ctr"/>
                       <a:r>
-                        <a:rPr sz="1050" b="0">
+                        <a:rPr sz="1100" b="0">
                           <a:solidFill>
                             <a:srgbClr val="111827"/>
                           </a:solidFill>
                         </a:rPr>
-                        <a:t>37%</a:t>
+                        <a:t>99/100</a:t>
                       </a:r>
                     </a:p>
                   </a:txBody>
@@ -19110,7 +16323,7 @@
                   </a:tcPr>
                 </a:tc>
               </a:tr>
-              <a:tr h="447040">
+              <a:tr h="509454">
                 <a:tc>
                   <a:txBody>
                     <a:bodyPr/>
@@ -19118,12 +16331,12 @@
                     <a:p>
                       <a:pPr algn="l"/>
                       <a:r>
-                        <a:rPr sz="1050" b="0">
+                        <a:rPr sz="1100" b="0">
                           <a:solidFill>
                             <a:srgbClr val="111827"/>
                           </a:solidFill>
                         </a:rPr>
-                        <a:t>First response, median</a:t>
+                        <a:t>Avg latency to reply</a:t>
                       </a:r>
                     </a:p>
                   </a:txBody>
@@ -19140,12 +16353,12 @@
                     <a:p>
                       <a:pPr algn="ctr"/>
                       <a:r>
-                        <a:rPr sz="1050" b="1">
+                        <a:rPr sz="1100" b="1">
                           <a:solidFill>
-                            <a:srgbClr val="059669"/>
+                            <a:srgbClr val="111827"/>
                           </a:solidFill>
                         </a:rPr>
-                        <a:t>0.7 ms</a:t>
+                        <a:t>12.1 s</a:t>
                       </a:r>
                     </a:p>
                   </a:txBody>
@@ -19162,148 +16375,12 @@
                     <a:p>
                       <a:pPr algn="ctr"/>
                       <a:r>
-                        <a:rPr sz="1050" b="0">
+                        <a:rPr sz="1100" b="0">
                           <a:solidFill>
                             <a:srgbClr val="111827"/>
                           </a:solidFill>
                         </a:rPr>
-                        <a:t>1,421 ms</a:t>
-                      </a:r>
-                    </a:p>
-                  </a:txBody>
-                  <a:tcPr>
-                    <a:solidFill>
-                      <a:srgbClr val="FFFFFF"/>
-                    </a:solidFill>
-                  </a:tcPr>
-                </a:tc>
-              </a:tr>
-              <a:tr h="447040">
-                <a:tc>
-                  <a:txBody>
-                    <a:bodyPr/>
-                    <a:lstStyle/>
-                    <a:p>
-                      <a:pPr algn="l"/>
-                      <a:r>
-                        <a:rPr sz="1050" b="0">
-                          <a:solidFill>
-                            <a:srgbClr val="111827"/>
-                          </a:solidFill>
-                        </a:rPr>
-                        <a:t>Max cancel latency</a:t>
-                      </a:r>
-                    </a:p>
-                  </a:txBody>
-                  <a:tcPr>
-                    <a:solidFill>
-                      <a:srgbClr val="F3F0FF"/>
-                    </a:solidFill>
-                  </a:tcPr>
-                </a:tc>
-                <a:tc>
-                  <a:txBody>
-                    <a:bodyPr/>
-                    <a:lstStyle/>
-                    <a:p>
-                      <a:pPr algn="ctr"/>
-                      <a:r>
-                        <a:rPr sz="1050" b="1">
-                          <a:solidFill>
-                            <a:srgbClr val="059669"/>
-                          </a:solidFill>
-                        </a:rPr>
-                        <a:t>4.5 ms</a:t>
-                      </a:r>
-                    </a:p>
-                  </a:txBody>
-                  <a:tcPr>
-                    <a:solidFill>
-                      <a:srgbClr val="F3F0FF"/>
-                    </a:solidFill>
-                  </a:tcPr>
-                </a:tc>
-                <a:tc>
-                  <a:txBody>
-                    <a:bodyPr/>
-                    <a:lstStyle/>
-                    <a:p>
-                      <a:pPr algn="ctr"/>
-                      <a:r>
-                        <a:rPr sz="1050" b="0">
-                          <a:solidFill>
-                            <a:srgbClr val="111827"/>
-                          </a:solidFill>
-                        </a:rPr>
-                        <a:t>never cancels</a:t>
-                      </a:r>
-                    </a:p>
-                  </a:txBody>
-                  <a:tcPr>
-                    <a:solidFill>
-                      <a:srgbClr val="F3F0FF"/>
-                    </a:solidFill>
-                  </a:tcPr>
-                </a:tc>
-              </a:tr>
-              <a:tr h="447040">
-                <a:tc>
-                  <a:txBody>
-                    <a:bodyPr/>
-                    <a:lstStyle/>
-                    <a:p>
-                      <a:pPr algn="l"/>
-                      <a:r>
-                        <a:rPr sz="1050" b="0">
-                          <a:solidFill>
-                            <a:srgbClr val="111827"/>
-                          </a:solidFill>
-                        </a:rPr>
-                        <a:t>Double bookings</a:t>
-                      </a:r>
-                    </a:p>
-                  </a:txBody>
-                  <a:tcPr>
-                    <a:solidFill>
-                      <a:srgbClr val="FFFFFF"/>
-                    </a:solidFill>
-                  </a:tcPr>
-                </a:tc>
-                <a:tc>
-                  <a:txBody>
-                    <a:bodyPr/>
-                    <a:lstStyle/>
-                    <a:p>
-                      <a:pPr algn="ctr"/>
-                      <a:r>
-                        <a:rPr sz="1050" b="1">
-                          <a:solidFill>
-                            <a:srgbClr val="059669"/>
-                          </a:solidFill>
-                        </a:rPr>
-                        <a:t>0</a:t>
-                      </a:r>
-                    </a:p>
-                  </a:txBody>
-                  <a:tcPr>
-                    <a:solidFill>
-                      <a:srgbClr val="FFFFFF"/>
-                    </a:solidFill>
-                  </a:tcPr>
-                </a:tc>
-                <a:tc>
-                  <a:txBody>
-                    <a:bodyPr/>
-                    <a:lstStyle/>
-                    <a:p>
-                      <a:pPr algn="ctr"/>
-                      <a:r>
-                        <a:rPr sz="1050" b="0">
-                          <a:solidFill>
-                            <a:srgbClr val="111827"/>
-                          </a:solidFill>
-                        </a:rPr>
-                        <a:t>1</a:t>
+                        <a:t>13.2 s</a:t>
                       </a:r>
                     </a:p>
                   </a:txBody>
@@ -19326,8 +16403,8 @@
         </p:nvSpPr>
         <p:spPr>
           <a:xfrm>
-            <a:off x="3977639" y="5806440"/>
-            <a:ext cx="4206240" cy="731520"/>
+            <a:off x="3977639" y="5394960"/>
+            <a:ext cx="4206240" cy="1097280"/>
           </a:xfrm>
           <a:prstGeom prst="rect">
             <a:avLst/>
@@ -19346,7 +16423,7 @@
                   <a:srgbClr val="475569"/>
                 </a:solidFill>
               </a:rPr>
-              <a:t>Baseline = same NLU and OCR, half-duplex control flow. Source: reports/results.json (python run_eval.py).</a:t>
+              <a:t>Audient column: the full run before the voice-detector and reply-guard fixes; the full run with them is pending. Source: reports/fdb/&lt;run&gt;/evaluate_*.txt, from FDB-v3's own scorers.</a:t>
             </a:r>
           </a:p>
         </p:txBody>
@@ -19402,7 +16479,7 @@
                   <a:srgbClr val="D97706"/>
                 </a:solidFill>
               </a:rPr>
-              <a:t>LIMITATIONS</a:t>
+              <a:t>WHAT HELD IT BACK</a:t>
             </a:r>
           </a:p>
           <a:p>
@@ -19417,7 +16494,7 @@
                   <a:srgbClr val="111827"/>
                 </a:solidFill>
               </a:rPr>
-              <a:t>• Own test suite: </a:t>
+              <a:t>• No reply: </a:t>
             </a:r>
             <a:r>
               <a:rPr sz="1150">
@@ -19425,7 +16502,7 @@
                   <a:srgbClr val="475569"/>
                 </a:solidFill>
               </a:rPr>
-              <a:t>the official kit wasn't released; the agent was tuned on these 15 scenarios.</a:t>
+              <a:t>LiveKit's Gemini plugin reported Gemini's replies as user speech, so calls were held up to 20 s.</a:t>
             </a:r>
           </a:p>
           <a:p>
@@ -19440,7 +16517,7 @@
                   <a:srgbClr val="111827"/>
                 </a:solidFill>
               </a:rPr>
-              <a:t>• </a:t>
+              <a:t>• Fixed: </a:t>
             </a:r>
             <a:r>
               <a:rPr sz="1150">
@@ -19448,7 +16525,7 @@
                   <a:srgbClr val="475569"/>
                 </a:solidFill>
               </a:rPr>
-              <a:t>Audio path not benchmarked (Whisper model not installed).</a:t>
+              <a:t>a local voice detector; of the 24 recordings that had gone silent, 18 now reply (was 6).</a:t>
             </a:r>
           </a:p>
           <a:p>
@@ -19463,7 +16540,7 @@
                   <a:srgbClr val="111827"/>
                 </a:solidFill>
               </a:rPr>
-              <a:t>• Rule-based NLU: </a:t>
+              <a:t>• Still silent: </a:t>
             </a:r>
             <a:r>
               <a:rPr sz="1150">
@@ -19471,7 +16548,7 @@
                   <a:srgbClr val="475569"/>
                 </a:solidFill>
               </a:rPr>
-              <a:t>limited gazetteers and entity types.</a:t>
+              <a:t>Gemini server errors (1011, 1007), outside our control.</a:t>
             </a:r>
           </a:p>
           <a:p>
@@ -19486,7 +16563,7 @@
                   <a:srgbClr val="111827"/>
                 </a:solidFill>
               </a:rPr>
-              <a:t>• </a:t>
+              <a:t>• Exact match: </a:t>
             </a:r>
             <a:r>
               <a:rPr sz="1150">
@@ -19494,30 +16571,7 @@
                   <a:srgbClr val="475569"/>
                 </a:solidFill>
               </a:rPr>
-              <a:t>No LED blink counting across frames yet.</a:t>
-            </a:r>
-          </a:p>
-          <a:p>
-            <a:pPr>
-              <a:spcBef>
-                <a:spcPts val="300"/>
-              </a:spcBef>
-            </a:pPr>
-            <a:r>
-              <a:rPr sz="1150" b="1">
-                <a:solidFill>
-                  <a:srgbClr val="111827"/>
-                </a:solidFill>
-              </a:rPr>
-              <a:t>• </a:t>
-            </a:r>
-            <a:r>
-              <a:rPr sz="1150">
-                <a:solidFill>
-                  <a:srgbClr val="475569"/>
-                </a:solidFill>
-              </a:rPr>
-              <a:t>Docker image not yet built or tested.</a:t>
+              <a:t>'3000' vs 3000 fails without the judge.</a:t>
             </a:r>
           </a:p>
         </p:txBody>
@@ -19639,7 +16693,7 @@
                   <a:srgbClr val="6D28D9"/>
                 </a:solidFill>
               </a:rPr>
-              <a:t>What's next: from verified prototype to hidden-set robustness and on-device</a:t>
+              <a:t>Turn the self-correction gain into a higher overall pass rate</a:t>
             </a:r>
           </a:p>
         </p:txBody>
@@ -19695,7 +16749,7 @@
                   <a:srgbClr val="2563EB"/>
                 </a:solidFill>
               </a:rPr>
-              <a:t>EVALUATION</a:t>
+              <a:t>BENCHMARK</a:t>
             </a:r>
           </a:p>
           <a:p>
@@ -19710,7 +16764,7 @@
                   <a:srgbClr val="111827"/>
                 </a:solidFill>
               </a:rPr>
-              <a:t>Plug into the official kit</a:t>
+              <a:t>Close the gap</a:t>
             </a:r>
           </a:p>
           <a:p>
@@ -19733,7 +16787,7 @@
                   <a:srgbClr val="475569"/>
                 </a:solidFill>
               </a:rPr>
-              <a:t>Map the released schema in protocol.adapt_event; run the 9 public + ~60 hidden-style scenarios.</a:t>
+              <a:t>Full run with the voice detector and reply guard; report it whatever it shows.</a:t>
             </a:r>
           </a:p>
           <a:p>
@@ -19748,7 +16802,7 @@
                   <a:srgbClr val="111827"/>
                 </a:solidFill>
               </a:rPr>
-              <a:t>• Adversarial-timing generator: </a:t>
+              <a:t>• </a:t>
             </a:r>
             <a:r>
               <a:rPr sz="1250">
@@ -19756,7 +16810,7 @@
                   <a:srgbClr val="475569"/>
                 </a:solidFill>
               </a:rPr>
-              <a:t>corrections landing at random offsets around tool completion.</a:t>
+              <a:t>Normalise argument formats (dates, numbers, IDs) before a call runs, so exact match and the judge agree.</a:t>
             </a:r>
           </a:p>
         </p:txBody>
@@ -19812,7 +16866,7 @@
                   <a:srgbClr val="059669"/>
                 </a:solidFill>
               </a:rPr>
-              <a:t>SPEECH</a:t>
+              <a:t>TURN-TAKING</a:t>
             </a:r>
           </a:p>
           <a:p>
@@ -19827,7 +16881,7 @@
                   <a:srgbClr val="111827"/>
                 </a:solidFill>
               </a:rPr>
-              <a:t>Streaming audio in the loop</a:t>
+              <a:t>Local end-of-turn</a:t>
             </a:r>
           </a:p>
           <a:p>
@@ -19850,7 +16904,7 @@
                   <a:srgbClr val="475569"/>
                 </a:solidFill>
               </a:rPr>
-              <a:t>Stream Whisper partial hypotheses into the speculative path; confidence-gated clarifications.</a:t>
+              <a:t>Move end-of-turn to the local voice detector once LiveKit's Gemini plugin supports manual turns.</a:t>
             </a:r>
           </a:p>
           <a:p>
@@ -19873,7 +16927,7 @@
                   <a:srgbClr val="475569"/>
                 </a:solidFill>
               </a:rPr>
-              <a:t>Acoustic cues (pitch drop, pause length) to complement the semantic end-of-turn check.</a:t>
+              <a:t>Handle Gemini's own call cancellations directly instead of asking again for the reply.</a:t>
             </a:r>
           </a:p>
         </p:txBody>
@@ -19929,7 +16983,7 @@
                   <a:srgbClr val="6D28D9"/>
                 </a:solidFill>
               </a:rPr>
-              <a:t>REASONING</a:t>
+              <a:t>EXTENSION</a:t>
             </a:r>
           </a:p>
           <a:p>
@@ -19944,7 +16998,7 @@
                   <a:srgbClr val="111827"/>
                 </a:solidFill>
               </a:rPr>
-              <a:t>LLM slow path, safely</a:t>
+              <a:t>Inside the LiveKit agent</a:t>
             </a:r>
           </a:p>
           <a:p>
@@ -19967,7 +17021,7 @@
                   <a:srgbClr val="475569"/>
                 </a:solidFill>
               </a:rPr>
-              <a:t>Optional LLM planner for open-ended requests; every extracted slot must be span-verified against the transcript before use.</a:t>
+              <a:t>Give the LiveKit agent the camera-troubleshooting tools, so the extension runs on the benchmark agent.</a:t>
             </a:r>
           </a:p>
           <a:p>
@@ -19990,7 +17044,7 @@
                   <a:srgbClr val="475569"/>
                 </a:solidFill>
               </a:rPr>
-              <a:t>Process-based perception workers to remove GIL contention entirely.</a:t>
+              <a:t>Blink-pattern recognition across frames, not just LED colour.</a:t>
             </a:r>
           </a:p>
         </p:txBody>
@@ -20076,7 +17130,7 @@
                   <a:srgbClr val="111827"/>
                 </a:solidFill>
               </a:rPr>
-              <a:t>• </a:t>
+              <a:t>• Plain Python: </a:t>
             </a:r>
             <a:r>
               <a:rPr sz="1250">
@@ -20084,7 +17138,7 @@
                   <a:srgbClr val="475569"/>
                 </a:solidFill>
               </a:rPr>
-              <a:t>The fast path is pure Python with no model on the critical path — a natural fit for on-device execution.</a:t>
+              <a:t>the coordination layer has no model on the critical path, a natural fit for on-device execution.</a:t>
             </a:r>
           </a:p>
           <a:p>
@@ -20107,7 +17161,7 @@
                   <a:srgbClr val="475569"/>
                 </a:solidFill>
               </a:rPr>
-              <a:t>Blink-pattern recognition from frame sequences for the troubleshooting extension.</a:t>
+              <a:t>Swap the hosted speech model for an on-device one behind the same layer.</a:t>
             </a:r>
           </a:p>
         </p:txBody>

</xml_diff>

<commit_message>
Deck: team Krenos, SRMIST, and the three members on the title and closing slides
Co-authored-by: hainasehrawat120 <180665540+hainasehrawat120@users.noreply.github.com>
</commit_message>
<xml_diff>
--- a/docs/SRMIST_krenos_Submission.pptx
+++ b/docs/SRMIST_krenos_Submission.pptx
@@ -12705,7 +12705,7 @@
         <p:spPr>
           <a:xfrm>
             <a:off x="777240" y="3703320"/>
-            <a:ext cx="5852160" cy="777240"/>
+            <a:ext cx="6766560" cy="777240"/>
           </a:xfrm>
           <a:prstGeom prst="rect">
             <a:avLst/>
@@ -12774,7 +12774,7 @@
                 <a:cs typeface="Calibri"/>
                 <a:sym typeface="Calibri"/>
               </a:rPr>
-              <a:t>Team Name -</a:t>
+              <a:t>Team Name - Krenos</a:t>
             </a:r>
             <a:endParaRPr/>
           </a:p>
@@ -12803,7 +12803,7 @@
                 <a:cs typeface="Calibri"/>
                 <a:sym typeface="Calibri"/>
               </a:rPr>
-              <a:t>College Name -</a:t>
+              <a:t>College Name - SRMIST</a:t>
             </a:r>
             <a:endParaRPr/>
           </a:p>
@@ -12832,7 +12832,7 @@
                 <a:cs typeface="Calibri"/>
                 <a:sym typeface="Calibri"/>
               </a:rPr>
-              <a:t>Member Name &amp; Email 1- </a:t>
+              <a:t>Member Name &amp; Email 1 - Haina Kumari, hainakumari1@gmail.com</a:t>
             </a:r>
             <a:endParaRPr/>
           </a:p>
@@ -12861,7 +12861,7 @@
                 <a:cs typeface="Calibri"/>
                 <a:sym typeface="Calibri"/>
               </a:rPr>
-              <a:t>Member Name &amp; Email 2-</a:t>
+              <a:t>Member Name &amp; Email 2 - Bipin Kumar, bipinkumar620013@gmail.com</a:t>
             </a:r>
             <a:endParaRPr/>
           </a:p>
@@ -12890,36 +12890,7 @@
                 <a:cs typeface="Calibri"/>
                 <a:sym typeface="Calibri"/>
               </a:rPr>
-              <a:t>Member Name &amp; Email 3- </a:t>
-            </a:r>
-            <a:endParaRPr/>
-          </a:p>
-          <a:p>
-            <a:pPr indent="-177800" lvl="0" marL="177800" marR="0" rtl="0" algn="l">
-              <a:spcBef>
-                <a:spcPts val="500"/>
-              </a:spcBef>
-              <a:spcAft>
-                <a:spcPts val="0"/>
-              </a:spcAft>
-              <a:buClr>
-                <a:srgbClr val="63637E"/>
-              </a:buClr>
-              <a:buSzPts val="1600"/>
-              <a:buFont typeface="Calibri"/>
-              <a:buChar char="•"/>
-            </a:pPr>
-            <a:r>
-              <a:rPr b="0" i="0" lang="en-US" sz="1600" u="none" cap="none" strike="noStrike">
-                <a:solidFill>
-                  <a:srgbClr val="63637E"/>
-                </a:solidFill>
-                <a:latin typeface="Calibri"/>
-                <a:ea typeface="Calibri"/>
-                <a:cs typeface="Calibri"/>
-                <a:sym typeface="Calibri"/>
-              </a:rPr>
-              <a:t>Member Name &amp; Email 4-</a:t>
+              <a:t>Member Name &amp; Email 3 - Titas Ghosh, titas.ghosh7@gmail.com</a:t>
             </a:r>
             <a:endParaRPr/>
           </a:p>
@@ -13490,7 +13461,7 @@
                   <a:srgbClr val="475569"/>
                 </a:solidFill>
               </a:rPr>
-              <a:t>Repository: github.com/Darsh-14/Audient   ·   Team: [Team Name], [College Name]</a:t>
+              <a:t>Repository: github.com/Darsh-14/Audient   ·   Team: Krenos, SRMIST</a:t>
             </a:r>
           </a:p>
         </p:txBody>

</xml_diff>